<commit_message>
Slides: one content type per slide, trimmed to fit
</commit_message>
<xml_diff>
--- a/slides.pptx
+++ b/slides.pptx
@@ -22,6 +22,8 @@
     <p:sldId id="270" r:id="rId16"/>
     <p:sldId id="271" r:id="rId17"/>
     <p:sldId id="272" r:id="rId18"/>
+    <p:sldId id="273" r:id="rId19"/>
+    <p:sldId id="274" r:id="rId20"/>
   </p:sldIdLst>
   <p:sldSz cx="9144000" cy="5143500" type="screen16x9"/>
   <p:notesSz cx="6858000" cy="9144000"/>
@@ -3239,6 +3241,112 @@
             </a:pPr>
             <a:r>
               <a:rPr/>
+              <a:t>Steps 1 and 2: what they say</a:t>
+            </a:r>
+          </a:p>
+        </p:txBody>
+      </p:sp>
+      <p:sp>
+        <p:nvSpPr>
+          <p:cNvPr id="3" name="Content Placeholder 2"/>
+          <p:cNvSpPr>
+            <a:spLocks noGrp="1"/>
+          </p:cNvSpPr>
+          <p:nvPr>
+            <p:ph idx="1"/>
+          </p:nvPr>
+        </p:nvSpPr>
+        <p:spPr/>
+        <p:txBody>
+          <a:bodyPr/>
+          <a:lstStyle/>
+          <a:p>
+            <a:pPr lvl="0"/>
+            <a:r>
+              <a:rPr b="1"/>
+              <a:t>Step 1: no.</a:t>
+            </a:r>
+            <a:r>
+              <a:rPr/>
+              <a:t> A new head on the frozen features doesn’t beat the detector’s own, and neither more head capacity nor reweighting the hard negatives changes that</a:t>
+            </a:r>
+          </a:p>
+          <a:p>
+            <a:pPr lvl="0"/>
+            <a:r>
+              <a:rPr/>
+              <a:t>The detector’s readout of its features is about as good as those features get: anything more needs new information, not a better readout</a:t>
+            </a:r>
+          </a:p>
+          <a:p>
+            <a:pPr lvl="0"/>
+            <a:r>
+              <a:rPr b="1"/>
+              <a:t>Step 2: yes, with a caveat.</a:t>
+            </a:r>
+            <a:r>
+              <a:rPr/>
+              <a:t> The second scan was the only change that moved validation, and it carried to test</a:t>
+            </a:r>
+          </a:p>
+          <a:p>
+            <a:pPr lvl="0"/>
+            <a:r>
+              <a:rPr/>
+              <a:t>But false alarms doubled at the same recall, and the paired interval on the gain, [−0.06, +0.16], includes zero</a:t>
+            </a:r>
+          </a:p>
+          <a:p>
+            <a:pPr lvl="0"/>
+            <a:r>
+              <a:rPr/>
+              <a:t>What it establishes: the second scan carries signal the first doesn’t</a:t>
+            </a:r>
+          </a:p>
+        </p:txBody>
+      </p:sp>
+    </p:spTree>
+  </p:cSld>
+</p:sld>
+</file>
+
+<file path=ppt/slides/slide11.xml><?xml version="1.0" encoding="utf-8"?>
+<p:sld xmlns:a="http://schemas.openxmlformats.org/drawingml/2006/main" xmlns:r="http://schemas.openxmlformats.org/officeDocument/2006/relationships" xmlns:p="http://schemas.openxmlformats.org/presentationml/2006/main">
+  <p:cSld>
+    <p:spTree>
+      <p:nvGrpSpPr>
+        <p:cNvPr id="1" name=""/>
+        <p:cNvGrpSpPr/>
+        <p:nvPr/>
+      </p:nvGrpSpPr>
+      <p:grpSpPr>
+        <a:xfrm>
+          <a:off x="0" y="0"/>
+          <a:ext cx="0" cy="0"/>
+          <a:chOff x="0" y="0"/>
+          <a:chExt cx="0" cy="0"/>
+        </a:xfrm>
+      </p:grpSpPr>
+      <p:sp>
+        <p:nvSpPr>
+          <p:cNvPr id="2" name="Title 1"/>
+          <p:cNvSpPr>
+            <a:spLocks noGrp="1"/>
+          </p:cNvSpPr>
+          <p:nvPr>
+            <p:ph type="title"/>
+          </p:nvPr>
+        </p:nvSpPr>
+        <p:spPr/>
+        <p:txBody>
+          <a:bodyPr/>
+          <a:lstStyle/>
+          <a:p>
+            <a:pPr lvl="0" indent="0" marL="0">
+              <a:buNone/>
+            </a:pPr>
+            <a:r>
+              <a:rPr/>
               <a:t>Steps 1 and 2: the picture</a:t>
             </a:r>
           </a:p>
@@ -3279,297 +3387,6 @@
 </p:sld>
 </file>
 
-<file path=ppt/slides/slide11.xml><?xml version="1.0" encoding="utf-8"?>
-<p:sld xmlns:a="http://schemas.openxmlformats.org/drawingml/2006/main" xmlns:r="http://schemas.openxmlformats.org/officeDocument/2006/relationships" xmlns:p="http://schemas.openxmlformats.org/presentationml/2006/main">
-  <p:cSld>
-    <p:spTree>
-      <p:nvGrpSpPr>
-        <p:cNvPr id="1" name=""/>
-        <p:cNvGrpSpPr/>
-        <p:nvPr/>
-      </p:nvGrpSpPr>
-      <p:grpSpPr>
-        <a:xfrm>
-          <a:off x="0" y="0"/>
-          <a:ext cx="0" cy="0"/>
-          <a:chOff x="0" y="0"/>
-          <a:chExt cx="0" cy="0"/>
-        </a:xfrm>
-      </p:grpSpPr>
-      <p:sp>
-        <p:nvSpPr>
-          <p:cNvPr id="2" name="Title 1"/>
-          <p:cNvSpPr>
-            <a:spLocks noGrp="1"/>
-          </p:cNvSpPr>
-          <p:nvPr>
-            <p:ph type="title"/>
-          </p:nvPr>
-        </p:nvSpPr>
-        <p:spPr>
-          <a:xfrm>
-            <a:off x="457201" y="204787"/>
-            <a:ext cx="3008313" cy="871538"/>
-          </a:xfrm>
-        </p:spPr>
-        <p:txBody>
-          <a:bodyPr/>
-          <a:lstStyle/>
-          <a:p>
-            <a:pPr lvl="0" indent="0" marL="0">
-              <a:buNone/>
-            </a:pPr>
-            <a:r>
-              <a:rPr/>
-              <a:t>Step 0: the stakes</a:t>
-            </a:r>
-          </a:p>
-        </p:txBody>
-      </p:sp>
-      <p:sp>
-        <p:nvSpPr>
-          <p:cNvPr id="4" name="Text Placeholder 3"/>
-          <p:cNvSpPr>
-            <a:spLocks noGrp="1"/>
-          </p:cNvSpPr>
-          <p:nvPr>
-            <p:ph idx="2" sz="half" type="body"/>
-          </p:nvPr>
-        </p:nvSpPr>
-        <p:spPr/>
-        <p:txBody>
-          <a:bodyPr/>
-          <a:lstStyle/>
-          <a:p>
-            <a:pPr lvl="0" indent="0" marL="0">
-              <a:buNone/>
-            </a:pPr>
-            <a:r>
-              <a:rPr/>
-              <a:t>Pre-onset AUC against warned storms, 2014–2015 test set, 495 pre-onset cases</a:t>
-            </a:r>
-          </a:p>
-        </p:txBody>
-      </p:sp>
-      <p:graphicFrame>
-        <p:nvGraphicFramePr>
-          <p:cNvPr id="6" name="Content Placeholder 5"/>
-          <p:cNvGraphicFramePr>
-            <a:graphicFrameLocks noGrp="1"/>
-          </p:cNvGraphicFramePr>
-          <p:nvPr>
-            <p:ph idx="1"/>
-          </p:nvPr>
-        </p:nvGraphicFramePr>
-        <p:xfrm>
-          <a:off x="3568700" y="203200"/>
-          <a:ext cx="5105400" cy="4381500"/>
-        </p:xfrm>
-        <a:graphic>
-          <a:graphicData uri="http://schemas.openxmlformats.org/drawingml/2006/table">
-            <a:tbl>
-              <a:tblPr firstRow="1" bandRow="1">
-                <a:tableStyleId>{5C22544A-7EE6-4342-B048-85BDC9FD1C3A}</a:tableStyleId>
-              </a:tblPr>
-              <a:tblGrid>
-                <a:gridCol w="1397000"/>
-                <a:gridCol w="1854200"/>
-                <a:gridCol w="1854200"/>
-              </a:tblGrid>
-              <a:tr h="0">
-                <a:tc>
-                  <a:txBody>
-                    <a:bodyPr/>
-                    <a:lstStyle/>
-                    <a:p>
-                      <a:endParaRPr/>
-                    </a:p>
-                  </a:txBody>
-                  <a:tcPr/>
-                </a:tc>
-                <a:tc>
-                  <a:txBody>
-                    <a:bodyPr/>
-                    <a:lstStyle/>
-                    <a:p>
-                      <a:pPr lvl="0" indent="0" marL="0" algn="ctr">
-                        <a:buNone/>
-                      </a:pPr>
-                      <a:r>
-                        <a:rPr/>
-                        <a:t>+5 min</a:t>
-                      </a:r>
-                    </a:p>
-                  </a:txBody>
-                  <a:tcPr/>
-                </a:tc>
-                <a:tc>
-                  <a:txBody>
-                    <a:bodyPr/>
-                    <a:lstStyle/>
-                    <a:p>
-                      <a:pPr lvl="0" indent="0" marL="0" algn="ctr">
-                        <a:buNone/>
-                      </a:pPr>
-                      <a:r>
-                        <a:rPr/>
-                        <a:t>+10 min</a:t>
-                      </a:r>
-                    </a:p>
-                  </a:txBody>
-                  <a:tcPr/>
-                </a:tc>
-              </a:tr>
-              <a:tr h="0">
-                <a:tc>
-                  <a:txBody>
-                    <a:bodyPr/>
-                    <a:lstStyle/>
-                    <a:p>
-                      <a:pPr lvl="0" indent="0" marL="0" algn="l">
-                        <a:buNone/>
-                      </a:pPr>
-                      <a:r>
-                        <a:rPr/>
-                        <a:t>floor: detector on the newest scan</a:t>
-                      </a:r>
-                    </a:p>
-                  </a:txBody>
-                </a:tc>
-                <a:tc>
-                  <a:txBody>
-                    <a:bodyPr/>
-                    <a:lstStyle/>
-                    <a:p>
-                      <a:pPr lvl="0" indent="0" marL="0" algn="ctr">
-                        <a:buNone/>
-                      </a:pPr>
-                      <a:r>
-                        <a:rPr/>
-                        <a:t>0.731</a:t>
-                      </a:r>
-                    </a:p>
-                  </a:txBody>
-                </a:tc>
-                <a:tc>
-                  <a:txBody>
-                    <a:bodyPr/>
-                    <a:lstStyle/>
-                    <a:p>
-                      <a:pPr lvl="0" indent="0" marL="0" algn="ctr">
-                        <a:buNone/>
-                      </a:pPr>
-                      <a:r>
-                        <a:rPr/>
-                        <a:t>0.726</a:t>
-                      </a:r>
-                    </a:p>
-                  </a:txBody>
-                </a:tc>
-              </a:tr>
-              <a:tr h="0">
-                <a:tc>
-                  <a:txBody>
-                    <a:bodyPr/>
-                    <a:lstStyle/>
-                    <a:p>
-                      <a:pPr lvl="0" indent="0" marL="0" algn="l">
-                        <a:buNone/>
-                      </a:pPr>
-                      <a:r>
-                        <a:rPr/>
-                        <a:t>ceiling: detector on the future scan</a:t>
-                      </a:r>
-                    </a:p>
-                  </a:txBody>
-                </a:tc>
-                <a:tc>
-                  <a:txBody>
-                    <a:bodyPr/>
-                    <a:lstStyle/>
-                    <a:p>
-                      <a:pPr lvl="0" indent="0" marL="0" algn="ctr">
-                        <a:buNone/>
-                      </a:pPr>
-                      <a:r>
-                        <a:rPr/>
-                        <a:t>0.769</a:t>
-                      </a:r>
-                    </a:p>
-                  </a:txBody>
-                </a:tc>
-                <a:tc>
-                  <a:txBody>
-                    <a:bodyPr/>
-                    <a:lstStyle/>
-                    <a:p>
-                      <a:pPr lvl="0" indent="0" marL="0" algn="ctr">
-                        <a:buNone/>
-                      </a:pPr>
-                      <a:r>
-                        <a:rPr/>
-                        <a:t>0.797</a:t>
-                      </a:r>
-                    </a:p>
-                  </a:txBody>
-                </a:tc>
-              </a:tr>
-              <a:tr h="0">
-                <a:tc>
-                  <a:txBody>
-                    <a:bodyPr/>
-                    <a:lstStyle/>
-                    <a:p>
-                      <a:pPr lvl="0" indent="0" marL="0" algn="l">
-                        <a:buNone/>
-                      </a:pPr>
-                      <a:r>
-                        <a:rPr/>
-                        <a:t>ceiling minus floor, paired</a:t>
-                      </a:r>
-                    </a:p>
-                  </a:txBody>
-                </a:tc>
-                <a:tc>
-                  <a:txBody>
-                    <a:bodyPr/>
-                    <a:lstStyle/>
-                    <a:p>
-                      <a:pPr lvl="0" indent="0" marL="0" algn="ctr">
-                        <a:buNone/>
-                      </a:pPr>
-                      <a:r>
-                        <a:rPr/>
-                        <a:t>+0.038 [+0.016, +0.063]</a:t>
-                      </a:r>
-                    </a:p>
-                  </a:txBody>
-                </a:tc>
-                <a:tc>
-                  <a:txBody>
-                    <a:bodyPr/>
-                    <a:lstStyle/>
-                    <a:p>
-                      <a:pPr lvl="0" indent="0" marL="0" algn="ctr">
-                        <a:buNone/>
-                      </a:pPr>
-                      <a:r>
-                        <a:rPr/>
-                        <a:t>+0.071 [+0.048, +0.093]</a:t>
-                      </a:r>
-                    </a:p>
-                  </a:txBody>
-                </a:tc>
-              </a:tr>
-            </a:tbl>
-          </a:graphicData>
-        </a:graphic>
-      </p:graphicFrame>
-    </p:spTree>
-  </p:cSld>
-</p:sld>
-</file>
-
 <file path=ppt/slides/slide12.xml><?xml version="1.0" encoding="utf-8"?>
 <p:sld xmlns:a="http://schemas.openxmlformats.org/drawingml/2006/main" xmlns:r="http://schemas.openxmlformats.org/officeDocument/2006/relationships" xmlns:p="http://schemas.openxmlformats.org/presentationml/2006/main">
   <p:cSld>
@@ -3589,34 +3406,249 @@
       </p:grpSpPr>
       <p:sp>
         <p:nvSpPr>
-          <p:cNvPr id="3" name="Content Placeholder 2"/>
-          <p:cNvSpPr>
-            <a:spLocks noGrp="1"/>
-          </p:cNvSpPr>
+          <p:cNvPr id="2" name="Title 1"/>
+          <p:cNvSpPr>
+            <a:spLocks noGrp="1"/>
+          </p:cNvSpPr>
+          <p:nvPr>
+            <p:ph type="title"/>
+          </p:nvPr>
+        </p:nvSpPr>
+        <p:spPr/>
+        <p:txBody>
+          <a:bodyPr/>
+          <a:lstStyle/>
+          <a:p>
+            <a:pPr lvl="0" indent="0" marL="0">
+              <a:buNone/>
+            </a:pPr>
+            <a:r>
+              <a:rPr/>
+              <a:t>Step 0: the stakes</a:t>
+            </a:r>
+          </a:p>
+        </p:txBody>
+      </p:sp>
+      <p:graphicFrame>
+        <p:nvGraphicFramePr>
+          <p:cNvPr id="6" name="Content Placeholder 5"/>
+          <p:cNvGraphicFramePr>
+            <a:graphicFrameLocks noGrp="1"/>
+          </p:cNvGraphicFramePr>
           <p:nvPr>
             <p:ph idx="1"/>
           </p:nvPr>
-        </p:nvSpPr>
-        <p:spPr/>
-        <p:txBody>
-          <a:bodyPr/>
-          <a:lstStyle/>
-          <a:p>
-            <a:pPr lvl="0"/>
-            <a:r>
-              <a:rPr/>
-              <a:t>The detector carried forward already scores 0.73: the signature is often half-formed five minutes before the label flips</a:t>
-            </a:r>
-          </a:p>
-          <a:p>
-            <a:pPr lvl="0"/>
-            <a:r>
-              <a:rPr/>
-              <a:t>The gap to the ceiling is the entire prize for forecasting the radar: 0.04 at +5, 0.07 at +10</a:t>
-            </a:r>
-          </a:p>
-        </p:txBody>
-      </p:sp>
+        </p:nvGraphicFramePr>
+        <p:xfrm>
+          <a:off x="457200" y="1193800"/>
+          <a:ext cx="8229600" cy="3390900"/>
+        </p:xfrm>
+        <a:graphic>
+          <a:graphicData uri="http://schemas.openxmlformats.org/drawingml/2006/table">
+            <a:tbl>
+              <a:tblPr firstRow="1" bandRow="1">
+                <a:tableStyleId>{5C22544A-7EE6-4342-B048-85BDC9FD1C3A}</a:tableStyleId>
+              </a:tblPr>
+              <a:tblGrid>
+                <a:gridCol w="2247900"/>
+                <a:gridCol w="2997200"/>
+                <a:gridCol w="2997200"/>
+              </a:tblGrid>
+              <a:tr h="0">
+                <a:tc>
+                  <a:txBody>
+                    <a:bodyPr/>
+                    <a:lstStyle/>
+                    <a:p>
+                      <a:pPr lvl="0" indent="0" marL="0" algn="l">
+                        <a:buNone/>
+                      </a:pPr>
+                      <a:r>
+                        <a:rPr/>
+                        <a:t>pre-onset AUC vs warned storms, 2014–2015</a:t>
+                      </a:r>
+                    </a:p>
+                  </a:txBody>
+                  <a:tcPr/>
+                </a:tc>
+                <a:tc>
+                  <a:txBody>
+                    <a:bodyPr/>
+                    <a:lstStyle/>
+                    <a:p>
+                      <a:pPr lvl="0" indent="0" marL="0" algn="ctr">
+                        <a:buNone/>
+                      </a:pPr>
+                      <a:r>
+                        <a:rPr/>
+                        <a:t>+5 min</a:t>
+                      </a:r>
+                    </a:p>
+                  </a:txBody>
+                  <a:tcPr/>
+                </a:tc>
+                <a:tc>
+                  <a:txBody>
+                    <a:bodyPr/>
+                    <a:lstStyle/>
+                    <a:p>
+                      <a:pPr lvl="0" indent="0" marL="0" algn="ctr">
+                        <a:buNone/>
+                      </a:pPr>
+                      <a:r>
+                        <a:rPr/>
+                        <a:t>+10 min</a:t>
+                      </a:r>
+                    </a:p>
+                  </a:txBody>
+                  <a:tcPr/>
+                </a:tc>
+              </a:tr>
+              <a:tr h="0">
+                <a:tc>
+                  <a:txBody>
+                    <a:bodyPr/>
+                    <a:lstStyle/>
+                    <a:p>
+                      <a:pPr lvl="0" indent="0" marL="0" algn="l">
+                        <a:buNone/>
+                      </a:pPr>
+                      <a:r>
+                        <a:rPr/>
+                        <a:t>floor: detector on the newest scan</a:t>
+                      </a:r>
+                    </a:p>
+                  </a:txBody>
+                </a:tc>
+                <a:tc>
+                  <a:txBody>
+                    <a:bodyPr/>
+                    <a:lstStyle/>
+                    <a:p>
+                      <a:pPr lvl="0" indent="0" marL="0" algn="ctr">
+                        <a:buNone/>
+                      </a:pPr>
+                      <a:r>
+                        <a:rPr/>
+                        <a:t>0.731</a:t>
+                      </a:r>
+                    </a:p>
+                  </a:txBody>
+                </a:tc>
+                <a:tc>
+                  <a:txBody>
+                    <a:bodyPr/>
+                    <a:lstStyle/>
+                    <a:p>
+                      <a:pPr lvl="0" indent="0" marL="0" algn="ctr">
+                        <a:buNone/>
+                      </a:pPr>
+                      <a:r>
+                        <a:rPr/>
+                        <a:t>0.726</a:t>
+                      </a:r>
+                    </a:p>
+                  </a:txBody>
+                </a:tc>
+              </a:tr>
+              <a:tr h="0">
+                <a:tc>
+                  <a:txBody>
+                    <a:bodyPr/>
+                    <a:lstStyle/>
+                    <a:p>
+                      <a:pPr lvl="0" indent="0" marL="0" algn="l">
+                        <a:buNone/>
+                      </a:pPr>
+                      <a:r>
+                        <a:rPr/>
+                        <a:t>ceiling: detector on the future scan</a:t>
+                      </a:r>
+                    </a:p>
+                  </a:txBody>
+                </a:tc>
+                <a:tc>
+                  <a:txBody>
+                    <a:bodyPr/>
+                    <a:lstStyle/>
+                    <a:p>
+                      <a:pPr lvl="0" indent="0" marL="0" algn="ctr">
+                        <a:buNone/>
+                      </a:pPr>
+                      <a:r>
+                        <a:rPr/>
+                        <a:t>0.769</a:t>
+                      </a:r>
+                    </a:p>
+                  </a:txBody>
+                </a:tc>
+                <a:tc>
+                  <a:txBody>
+                    <a:bodyPr/>
+                    <a:lstStyle/>
+                    <a:p>
+                      <a:pPr lvl="0" indent="0" marL="0" algn="ctr">
+                        <a:buNone/>
+                      </a:pPr>
+                      <a:r>
+                        <a:rPr/>
+                        <a:t>0.797</a:t>
+                      </a:r>
+                    </a:p>
+                  </a:txBody>
+                </a:tc>
+              </a:tr>
+              <a:tr h="0">
+                <a:tc>
+                  <a:txBody>
+                    <a:bodyPr/>
+                    <a:lstStyle/>
+                    <a:p>
+                      <a:pPr lvl="0" indent="0" marL="0" algn="l">
+                        <a:buNone/>
+                      </a:pPr>
+                      <a:r>
+                        <a:rPr/>
+                        <a:t>ceiling minus floor, paired</a:t>
+                      </a:r>
+                    </a:p>
+                  </a:txBody>
+                </a:tc>
+                <a:tc>
+                  <a:txBody>
+                    <a:bodyPr/>
+                    <a:lstStyle/>
+                    <a:p>
+                      <a:pPr lvl="0" indent="0" marL="0" algn="ctr">
+                        <a:buNone/>
+                      </a:pPr>
+                      <a:r>
+                        <a:rPr/>
+                        <a:t>+0.038 [+0.016, +0.063]</a:t>
+                      </a:r>
+                    </a:p>
+                  </a:txBody>
+                </a:tc>
+                <a:tc>
+                  <a:txBody>
+                    <a:bodyPr/>
+                    <a:lstStyle/>
+                    <a:p>
+                      <a:pPr lvl="0" indent="0" marL="0" algn="ctr">
+                        <a:buNone/>
+                      </a:pPr>
+                      <a:r>
+                        <a:rPr/>
+                        <a:t>+0.071 [+0.048, +0.093]</a:t>
+                      </a:r>
+                    </a:p>
+                  </a:txBody>
+                </a:tc>
+              </a:tr>
+            </a:tbl>
+          </a:graphicData>
+        </a:graphic>
+      </p:graphicFrame>
     </p:spTree>
   </p:cSld>
 </p:sld>
@@ -3659,402 +3691,48 @@
             </a:pPr>
             <a:r>
               <a:rPr/>
-              <a:t>Steps 3 and 4: the onset task</a:t>
-            </a:r>
-          </a:p>
-        </p:txBody>
-      </p:sp>
-      <p:graphicFrame>
-        <p:nvGraphicFramePr>
-          <p:cNvPr id="6" name="Content Placeholder 5"/>
-          <p:cNvGraphicFramePr>
-            <a:graphicFrameLocks noGrp="1"/>
-          </p:cNvGraphicFramePr>
+              <a:t>Step 0: what it says</a:t>
+            </a:r>
+          </a:p>
+        </p:txBody>
+      </p:sp>
+      <p:sp>
+        <p:nvSpPr>
+          <p:cNvPr id="3" name="Content Placeholder 2"/>
+          <p:cNvSpPr>
+            <a:spLocks noGrp="1"/>
+          </p:cNvSpPr>
           <p:nvPr>
             <p:ph idx="1"/>
           </p:nvPr>
-        </p:nvGraphicFramePr>
-        <p:xfrm>
-          <a:off x="457200" y="1193800"/>
-          <a:ext cx="8229600" cy="3390900"/>
-        </p:xfrm>
-        <a:graphic>
-          <a:graphicData uri="http://schemas.openxmlformats.org/drawingml/2006/table">
-            <a:tbl>
-              <a:tblPr firstRow="1" bandRow="1">
-                <a:tableStyleId>{5C22544A-7EE6-4342-B048-85BDC9FD1C3A}</a:tableStyleId>
-              </a:tblPr>
-              <a:tblGrid>
-                <a:gridCol w="1295400"/>
-                <a:gridCol w="1727200"/>
-                <a:gridCol w="1727200"/>
-                <a:gridCol w="1727200"/>
-                <a:gridCol w="1727200"/>
-              </a:tblGrid>
-              <a:tr h="0">
-                <a:tc>
-                  <a:txBody>
-                    <a:bodyPr/>
-                    <a:lstStyle/>
-                    <a:p>
-                      <a:endParaRPr/>
-                    </a:p>
-                  </a:txBody>
-                  <a:tcPr/>
-                </a:tc>
-                <a:tc>
-                  <a:txBody>
-                    <a:bodyPr/>
-                    <a:lstStyle/>
-                    <a:p>
-                      <a:pPr lvl="0" indent="0" marL="0" algn="ctr">
-                        <a:buNone/>
-                      </a:pPr>
-                      <a:r>
-                        <a:rPr/>
-                        <a:t>+5 min</a:t>
-                      </a:r>
-                    </a:p>
-                  </a:txBody>
-                  <a:tcPr/>
-                </a:tc>
-                <a:tc>
-                  <a:txBody>
-                    <a:bodyPr/>
-                    <a:lstStyle/>
-                    <a:p>
-                      <a:pPr lvl="0" indent="0" marL="0" algn="ctr">
-                        <a:buNone/>
-                      </a:pPr>
-                      <a:r>
-                        <a:rPr/>
-                        <a:t>paired vs floor</a:t>
-                      </a:r>
-                    </a:p>
-                  </a:txBody>
-                  <a:tcPr/>
-                </a:tc>
-                <a:tc>
-                  <a:txBody>
-                    <a:bodyPr/>
-                    <a:lstStyle/>
-                    <a:p>
-                      <a:pPr lvl="0" indent="0" marL="0" algn="ctr">
-                        <a:buNone/>
-                      </a:pPr>
-                      <a:r>
-                        <a:rPr/>
-                        <a:t>+10 min</a:t>
-                      </a:r>
-                    </a:p>
-                  </a:txBody>
-                  <a:tcPr/>
-                </a:tc>
-                <a:tc>
-                  <a:txBody>
-                    <a:bodyPr/>
-                    <a:lstStyle/>
-                    <a:p>
-                      <a:pPr lvl="0" indent="0" marL="0" algn="ctr">
-                        <a:buNone/>
-                      </a:pPr>
-                      <a:r>
-                        <a:rPr/>
-                        <a:t>paired vs floor</a:t>
-                      </a:r>
-                    </a:p>
-                  </a:txBody>
-                  <a:tcPr/>
-                </a:tc>
-              </a:tr>
-              <a:tr h="0">
-                <a:tc>
-                  <a:txBody>
-                    <a:bodyPr/>
-                    <a:lstStyle/>
-                    <a:p>
-                      <a:pPr lvl="0" indent="0" marL="0" algn="l">
-                        <a:buNone/>
-                      </a:pPr>
-                      <a:r>
-                        <a:rPr/>
-                        <a:t>floor</a:t>
-                      </a:r>
-                    </a:p>
-                  </a:txBody>
-                </a:tc>
-                <a:tc>
-                  <a:txBody>
-                    <a:bodyPr/>
-                    <a:lstStyle/>
-                    <a:p>
-                      <a:pPr lvl="0" indent="0" marL="0" algn="ctr">
-                        <a:buNone/>
-                      </a:pPr>
-                      <a:r>
-                        <a:rPr/>
-                        <a:t>0.731</a:t>
-                      </a:r>
-                    </a:p>
-                  </a:txBody>
-                </a:tc>
-                <a:tc>
-                  <a:txBody>
-                    <a:bodyPr/>
-                    <a:lstStyle/>
-                    <a:p>
-                      <a:endParaRPr/>
-                    </a:p>
-                  </a:txBody>
-                </a:tc>
-                <a:tc>
-                  <a:txBody>
-                    <a:bodyPr/>
-                    <a:lstStyle/>
-                    <a:p>
-                      <a:pPr lvl="0" indent="0" marL="0" algn="ctr">
-                        <a:buNone/>
-                      </a:pPr>
-                      <a:r>
-                        <a:rPr/>
-                        <a:t>0.726</a:t>
-                      </a:r>
-                    </a:p>
-                  </a:txBody>
-                </a:tc>
-                <a:tc>
-                  <a:txBody>
-                    <a:bodyPr/>
-                    <a:lstStyle/>
-                    <a:p>
-                      <a:endParaRPr/>
-                    </a:p>
-                  </a:txBody>
-                </a:tc>
-              </a:tr>
-              <a:tr h="0">
-                <a:tc>
-                  <a:txBody>
-                    <a:bodyPr/>
-                    <a:lstStyle/>
-                    <a:p>
-                      <a:pPr lvl="0" indent="0" marL="0" algn="l">
-                        <a:buNone/>
-                      </a:pPr>
-                      <a:r>
-                        <a:rPr/>
-                        <a:t>3: frozen CNN, two scans, new head</a:t>
-                      </a:r>
-                    </a:p>
-                  </a:txBody>
-                </a:tc>
-                <a:tc>
-                  <a:txBody>
-                    <a:bodyPr/>
-                    <a:lstStyle/>
-                    <a:p>
-                      <a:pPr lvl="0" indent="0" marL="0" algn="ctr">
-                        <a:buNone/>
-                      </a:pPr>
-                      <a:r>
-                        <a:rPr/>
-                        <a:t>0.699</a:t>
-                      </a:r>
-                    </a:p>
-                  </a:txBody>
-                </a:tc>
-                <a:tc>
-                  <a:txBody>
-                    <a:bodyPr/>
-                    <a:lstStyle/>
-                    <a:p>
-                      <a:pPr lvl="0" indent="0" marL="0" algn="ctr">
-                        <a:buNone/>
-                      </a:pPr>
-                      <a:r>
-                        <a:rPr/>
-                        <a:t>−0.032 [−0.045, −0.020]</a:t>
-                      </a:r>
-                    </a:p>
-                  </a:txBody>
-                </a:tc>
-                <a:tc>
-                  <a:txBody>
-                    <a:bodyPr/>
-                    <a:lstStyle/>
-                    <a:p>
-                      <a:pPr lvl="0" indent="0" marL="0" algn="ctr">
-                        <a:buNone/>
-                      </a:pPr>
-                      <a:r>
-                        <a:rPr/>
-                        <a:t>0.710</a:t>
-                      </a:r>
-                    </a:p>
-                  </a:txBody>
-                </a:tc>
-                <a:tc>
-                  <a:txBody>
-                    <a:bodyPr/>
-                    <a:lstStyle/>
-                    <a:p>
-                      <a:pPr lvl="0" indent="0" marL="0" algn="ctr">
-                        <a:buNone/>
-                      </a:pPr>
-                      <a:r>
-                        <a:rPr/>
-                        <a:t>−0.017 [−0.024, −0.010]</a:t>
-                      </a:r>
-                    </a:p>
-                  </a:txBody>
-                </a:tc>
-              </a:tr>
-              <a:tr h="0">
-                <a:tc>
-                  <a:txBody>
-                    <a:bodyPr/>
-                    <a:lstStyle/>
-                    <a:p>
-                      <a:pPr lvl="0" indent="0" marL="0" algn="l">
-                        <a:buNone/>
-                      </a:pPr>
-                      <a:r>
-                        <a:rPr/>
-                        <a:t>4: fine-tuned</a:t>
-                      </a:r>
-                    </a:p>
-                  </a:txBody>
-                </a:tc>
-                <a:tc>
-                  <a:txBody>
-                    <a:bodyPr/>
-                    <a:lstStyle/>
-                    <a:p>
-                      <a:pPr lvl="0" indent="0" marL="0" algn="ctr">
-                        <a:buNone/>
-                      </a:pPr>
-                      <a:r>
-                        <a:rPr/>
-                        <a:t>0.724</a:t>
-                      </a:r>
-                    </a:p>
-                  </a:txBody>
-                </a:tc>
-                <a:tc>
-                  <a:txBody>
-                    <a:bodyPr/>
-                    <a:lstStyle/>
-                    <a:p>
-                      <a:pPr lvl="0" indent="0" marL="0" algn="ctr">
-                        <a:buNone/>
-                      </a:pPr>
-                      <a:r>
-                        <a:rPr/>
-                        <a:t>−0.007 [−0.031, +0.015]</a:t>
-                      </a:r>
-                    </a:p>
-                  </a:txBody>
-                </a:tc>
-                <a:tc>
-                  <a:txBody>
-                    <a:bodyPr/>
-                    <a:lstStyle/>
-                    <a:p>
-                      <a:pPr lvl="0" indent="0" marL="0" algn="ctr">
-                        <a:buNone/>
-                      </a:pPr>
-                      <a:r>
-                        <a:rPr/>
-                        <a:t>0.728</a:t>
-                      </a:r>
-                    </a:p>
-                  </a:txBody>
-                </a:tc>
-                <a:tc>
-                  <a:txBody>
-                    <a:bodyPr/>
-                    <a:lstStyle/>
-                    <a:p>
-                      <a:pPr lvl="0" indent="0" marL="0" algn="ctr">
-                        <a:buNone/>
-                      </a:pPr>
-                      <a:r>
-                        <a:rPr/>
-                        <a:t>+0.001 [−0.016, +0.018]</a:t>
-                      </a:r>
-                    </a:p>
-                  </a:txBody>
-                </a:tc>
-              </a:tr>
-              <a:tr h="0">
-                <a:tc>
-                  <a:txBody>
-                    <a:bodyPr/>
-                    <a:lstStyle/>
-                    <a:p>
-                      <a:pPr lvl="0" indent="0" marL="0" algn="l">
-                        <a:buNone/>
-                      </a:pPr>
-                      <a:r>
-                        <a:rPr/>
-                        <a:t>ceiling</a:t>
-                      </a:r>
-                    </a:p>
-                  </a:txBody>
-                </a:tc>
-                <a:tc>
-                  <a:txBody>
-                    <a:bodyPr/>
-                    <a:lstStyle/>
-                    <a:p>
-                      <a:pPr lvl="0" indent="0" marL="0" algn="ctr">
-                        <a:buNone/>
-                      </a:pPr>
-                      <a:r>
-                        <a:rPr/>
-                        <a:t>0.769</a:t>
-                      </a:r>
-                    </a:p>
-                  </a:txBody>
-                </a:tc>
-                <a:tc>
-                  <a:txBody>
-                    <a:bodyPr/>
-                    <a:lstStyle/>
-                    <a:p>
-                      <a:endParaRPr/>
-                    </a:p>
-                  </a:txBody>
-                </a:tc>
-                <a:tc>
-                  <a:txBody>
-                    <a:bodyPr/>
-                    <a:lstStyle/>
-                    <a:p>
-                      <a:pPr lvl="0" indent="0" marL="0" algn="ctr">
-                        <a:buNone/>
-                      </a:pPr>
-                      <a:r>
-                        <a:rPr/>
-                        <a:t>0.797</a:t>
-                      </a:r>
-                    </a:p>
-                  </a:txBody>
-                </a:tc>
-                <a:tc>
-                  <a:txBody>
-                    <a:bodyPr/>
-                    <a:lstStyle/>
-                    <a:p>
-                      <a:endParaRPr/>
-                    </a:p>
-                  </a:txBody>
-                </a:tc>
-              </a:tr>
-            </a:tbl>
-          </a:graphicData>
-        </a:graphic>
-      </p:graphicFrame>
+        </p:nvSpPr>
+        <p:spPr/>
+        <p:txBody>
+          <a:bodyPr/>
+          <a:lstStyle/>
+          <a:p>
+            <a:pPr lvl="0"/>
+            <a:r>
+              <a:rPr/>
+              <a:t>The detector carried forward already scores 0.73 on 495 pre-onset cases: the signature is often half-formed five minutes before the label flips</a:t>
+            </a:r>
+          </a:p>
+          <a:p>
+            <a:pPr lvl="0"/>
+            <a:r>
+              <a:rPr/>
+              <a:t>The gap to the ceiling is the entire prize for forecasting the radar: 0.04 at +5, 0.07 at +10</a:t>
+            </a:r>
+          </a:p>
+          <a:p>
+            <a:pPr lvl="0"/>
+            <a:r>
+              <a:rPr/>
+              <a:t>Even a perfect picture of the next scan, read by this detector, adds that much and no more. Anything steps 3 and 4 gain has to fit inside it</a:t>
+            </a:r>
+          </a:p>
+        </p:txBody>
+      </p:sp>
     </p:spTree>
   </p:cSld>
 </p:sld>
@@ -4079,55 +3757,531 @@
       </p:grpSpPr>
       <p:sp>
         <p:nvSpPr>
-          <p:cNvPr id="3" name="Content Placeholder 2"/>
-          <p:cNvSpPr>
-            <a:spLocks noGrp="1"/>
-          </p:cNvSpPr>
+          <p:cNvPr id="2" name="Title 1"/>
+          <p:cNvSpPr>
+            <a:spLocks noGrp="1"/>
+          </p:cNvSpPr>
+          <p:nvPr>
+            <p:ph type="title"/>
+          </p:nvPr>
+        </p:nvSpPr>
+        <p:spPr/>
+        <p:txBody>
+          <a:bodyPr/>
+          <a:lstStyle/>
+          <a:p>
+            <a:pPr lvl="0" indent="0" marL="0">
+              <a:buNone/>
+            </a:pPr>
+            <a:r>
+              <a:rPr/>
+              <a:t>Steps 3 and 4: the onset task</a:t>
+            </a:r>
+          </a:p>
+        </p:txBody>
+      </p:sp>
+      <p:graphicFrame>
+        <p:nvGraphicFramePr>
+          <p:cNvPr id="6" name="Content Placeholder 5"/>
+          <p:cNvGraphicFramePr>
+            <a:graphicFrameLocks noGrp="1"/>
+          </p:cNvGraphicFramePr>
           <p:nvPr>
             <p:ph idx="1"/>
           </p:nvPr>
-        </p:nvSpPr>
-        <p:spPr/>
-        <p:txBody>
-          <a:bodyPr/>
-          <a:lstStyle/>
-          <a:p>
-            <a:pPr lvl="0"/>
-            <a:r>
-              <a:rPr b="1"/>
-              <a:t>Step 3 lands below the floor</a:t>
-            </a:r>
-            <a:r>
-              <a:rPr/>
-              <a:t>, and not by noise: step 1’s answer again on the harder task</a:t>
-            </a:r>
-          </a:p>
-          <a:p>
-            <a:pPr lvl="0"/>
-            <a:r>
-              <a:rPr b="1"/>
-              <a:t>Step 4 recovers the floor and no more.</a:t>
-            </a:r>
-            <a:r>
-              <a:rPr/>
-              <a:t> Fine-tuning lifts the head by about 0.02 to a tie with the detector; validation was still rising at the epoch cap</a:t>
-            </a:r>
-          </a:p>
-          <a:p>
-            <a:pPr lvl="0"/>
-            <a:r>
-              <a:rPr/>
-              <a:t>Same picture in each year: ties the floor in 2015, trails it in 2014</a:t>
-            </a:r>
-          </a:p>
-        </p:txBody>
-      </p:sp>
+        </p:nvGraphicFramePr>
+        <p:xfrm>
+          <a:off x="457200" y="1193800"/>
+          <a:ext cx="8229600" cy="3390900"/>
+        </p:xfrm>
+        <a:graphic>
+          <a:graphicData uri="http://schemas.openxmlformats.org/drawingml/2006/table">
+            <a:tbl>
+              <a:tblPr firstRow="1" bandRow="1">
+                <a:tableStyleId>{5C22544A-7EE6-4342-B048-85BDC9FD1C3A}</a:tableStyleId>
+              </a:tblPr>
+              <a:tblGrid>
+                <a:gridCol w="1295400"/>
+                <a:gridCol w="1727200"/>
+                <a:gridCol w="1727200"/>
+                <a:gridCol w="1727200"/>
+                <a:gridCol w="1727200"/>
+              </a:tblGrid>
+              <a:tr h="0">
+                <a:tc>
+                  <a:txBody>
+                    <a:bodyPr/>
+                    <a:lstStyle/>
+                    <a:p>
+                      <a:pPr lvl="0" indent="0" marL="0" algn="l">
+                        <a:buNone/>
+                      </a:pPr>
+                      <a:r>
+                        <a:rPr/>
+                        <a:t>pre-onset AUC vs warned storms</a:t>
+                      </a:r>
+                    </a:p>
+                  </a:txBody>
+                  <a:tcPr/>
+                </a:tc>
+                <a:tc>
+                  <a:txBody>
+                    <a:bodyPr/>
+                    <a:lstStyle/>
+                    <a:p>
+                      <a:pPr lvl="0" indent="0" marL="0" algn="ctr">
+                        <a:buNone/>
+                      </a:pPr>
+                      <a:r>
+                        <a:rPr/>
+                        <a:t>+5 min</a:t>
+                      </a:r>
+                    </a:p>
+                  </a:txBody>
+                  <a:tcPr/>
+                </a:tc>
+                <a:tc>
+                  <a:txBody>
+                    <a:bodyPr/>
+                    <a:lstStyle/>
+                    <a:p>
+                      <a:pPr lvl="0" indent="0" marL="0" algn="ctr">
+                        <a:buNone/>
+                      </a:pPr>
+                      <a:r>
+                        <a:rPr/>
+                        <a:t>paired vs floor</a:t>
+                      </a:r>
+                    </a:p>
+                  </a:txBody>
+                  <a:tcPr/>
+                </a:tc>
+                <a:tc>
+                  <a:txBody>
+                    <a:bodyPr/>
+                    <a:lstStyle/>
+                    <a:p>
+                      <a:pPr lvl="0" indent="0" marL="0" algn="ctr">
+                        <a:buNone/>
+                      </a:pPr>
+                      <a:r>
+                        <a:rPr/>
+                        <a:t>+10 min</a:t>
+                      </a:r>
+                    </a:p>
+                  </a:txBody>
+                  <a:tcPr/>
+                </a:tc>
+                <a:tc>
+                  <a:txBody>
+                    <a:bodyPr/>
+                    <a:lstStyle/>
+                    <a:p>
+                      <a:pPr lvl="0" indent="0" marL="0" algn="ctr">
+                        <a:buNone/>
+                      </a:pPr>
+                      <a:r>
+                        <a:rPr/>
+                        <a:t>paired vs floor</a:t>
+                      </a:r>
+                    </a:p>
+                  </a:txBody>
+                  <a:tcPr/>
+                </a:tc>
+              </a:tr>
+              <a:tr h="0">
+                <a:tc>
+                  <a:txBody>
+                    <a:bodyPr/>
+                    <a:lstStyle/>
+                    <a:p>
+                      <a:pPr lvl="0" indent="0" marL="0" algn="l">
+                        <a:buNone/>
+                      </a:pPr>
+                      <a:r>
+                        <a:rPr/>
+                        <a:t>floor</a:t>
+                      </a:r>
+                    </a:p>
+                  </a:txBody>
+                </a:tc>
+                <a:tc>
+                  <a:txBody>
+                    <a:bodyPr/>
+                    <a:lstStyle/>
+                    <a:p>
+                      <a:pPr lvl="0" indent="0" marL="0" algn="ctr">
+                        <a:buNone/>
+                      </a:pPr>
+                      <a:r>
+                        <a:rPr/>
+                        <a:t>0.731</a:t>
+                      </a:r>
+                    </a:p>
+                  </a:txBody>
+                </a:tc>
+                <a:tc>
+                  <a:txBody>
+                    <a:bodyPr/>
+                    <a:lstStyle/>
+                    <a:p>
+                      <a:endParaRPr/>
+                    </a:p>
+                  </a:txBody>
+                </a:tc>
+                <a:tc>
+                  <a:txBody>
+                    <a:bodyPr/>
+                    <a:lstStyle/>
+                    <a:p>
+                      <a:pPr lvl="0" indent="0" marL="0" algn="ctr">
+                        <a:buNone/>
+                      </a:pPr>
+                      <a:r>
+                        <a:rPr/>
+                        <a:t>0.726</a:t>
+                      </a:r>
+                    </a:p>
+                  </a:txBody>
+                </a:tc>
+                <a:tc>
+                  <a:txBody>
+                    <a:bodyPr/>
+                    <a:lstStyle/>
+                    <a:p>
+                      <a:endParaRPr/>
+                    </a:p>
+                  </a:txBody>
+                </a:tc>
+              </a:tr>
+              <a:tr h="0">
+                <a:tc>
+                  <a:txBody>
+                    <a:bodyPr/>
+                    <a:lstStyle/>
+                    <a:p>
+                      <a:pPr lvl="0" indent="0" marL="0" algn="l">
+                        <a:buNone/>
+                      </a:pPr>
+                      <a:r>
+                        <a:rPr/>
+                        <a:t>3: frozen CNN, two scans, new head</a:t>
+                      </a:r>
+                    </a:p>
+                  </a:txBody>
+                </a:tc>
+                <a:tc>
+                  <a:txBody>
+                    <a:bodyPr/>
+                    <a:lstStyle/>
+                    <a:p>
+                      <a:pPr lvl="0" indent="0" marL="0" algn="ctr">
+                        <a:buNone/>
+                      </a:pPr>
+                      <a:r>
+                        <a:rPr/>
+                        <a:t>0.699</a:t>
+                      </a:r>
+                    </a:p>
+                  </a:txBody>
+                </a:tc>
+                <a:tc>
+                  <a:txBody>
+                    <a:bodyPr/>
+                    <a:lstStyle/>
+                    <a:p>
+                      <a:pPr lvl="0" indent="0" marL="0" algn="ctr">
+                        <a:buNone/>
+                      </a:pPr>
+                      <a:r>
+                        <a:rPr/>
+                        <a:t>−0.032 [−0.045, −0.020]</a:t>
+                      </a:r>
+                    </a:p>
+                  </a:txBody>
+                </a:tc>
+                <a:tc>
+                  <a:txBody>
+                    <a:bodyPr/>
+                    <a:lstStyle/>
+                    <a:p>
+                      <a:pPr lvl="0" indent="0" marL="0" algn="ctr">
+                        <a:buNone/>
+                      </a:pPr>
+                      <a:r>
+                        <a:rPr/>
+                        <a:t>0.710</a:t>
+                      </a:r>
+                    </a:p>
+                  </a:txBody>
+                </a:tc>
+                <a:tc>
+                  <a:txBody>
+                    <a:bodyPr/>
+                    <a:lstStyle/>
+                    <a:p>
+                      <a:pPr lvl="0" indent="0" marL="0" algn="ctr">
+                        <a:buNone/>
+                      </a:pPr>
+                      <a:r>
+                        <a:rPr/>
+                        <a:t>−0.017 [−0.024, −0.010]</a:t>
+                      </a:r>
+                    </a:p>
+                  </a:txBody>
+                </a:tc>
+              </a:tr>
+              <a:tr h="0">
+                <a:tc>
+                  <a:txBody>
+                    <a:bodyPr/>
+                    <a:lstStyle/>
+                    <a:p>
+                      <a:pPr lvl="0" indent="0" marL="0" algn="l">
+                        <a:buNone/>
+                      </a:pPr>
+                      <a:r>
+                        <a:rPr/>
+                        <a:t>4: fine-tuned</a:t>
+                      </a:r>
+                    </a:p>
+                  </a:txBody>
+                </a:tc>
+                <a:tc>
+                  <a:txBody>
+                    <a:bodyPr/>
+                    <a:lstStyle/>
+                    <a:p>
+                      <a:pPr lvl="0" indent="0" marL="0" algn="ctr">
+                        <a:buNone/>
+                      </a:pPr>
+                      <a:r>
+                        <a:rPr/>
+                        <a:t>0.724</a:t>
+                      </a:r>
+                    </a:p>
+                  </a:txBody>
+                </a:tc>
+                <a:tc>
+                  <a:txBody>
+                    <a:bodyPr/>
+                    <a:lstStyle/>
+                    <a:p>
+                      <a:pPr lvl="0" indent="0" marL="0" algn="ctr">
+                        <a:buNone/>
+                      </a:pPr>
+                      <a:r>
+                        <a:rPr/>
+                        <a:t>−0.007 [−0.031, +0.015]</a:t>
+                      </a:r>
+                    </a:p>
+                  </a:txBody>
+                </a:tc>
+                <a:tc>
+                  <a:txBody>
+                    <a:bodyPr/>
+                    <a:lstStyle/>
+                    <a:p>
+                      <a:pPr lvl="0" indent="0" marL="0" algn="ctr">
+                        <a:buNone/>
+                      </a:pPr>
+                      <a:r>
+                        <a:rPr/>
+                        <a:t>0.728</a:t>
+                      </a:r>
+                    </a:p>
+                  </a:txBody>
+                </a:tc>
+                <a:tc>
+                  <a:txBody>
+                    <a:bodyPr/>
+                    <a:lstStyle/>
+                    <a:p>
+                      <a:pPr lvl="0" indent="0" marL="0" algn="ctr">
+                        <a:buNone/>
+                      </a:pPr>
+                      <a:r>
+                        <a:rPr/>
+                        <a:t>+0.001 [−0.016, +0.018]</a:t>
+                      </a:r>
+                    </a:p>
+                  </a:txBody>
+                </a:tc>
+              </a:tr>
+              <a:tr h="0">
+                <a:tc>
+                  <a:txBody>
+                    <a:bodyPr/>
+                    <a:lstStyle/>
+                    <a:p>
+                      <a:pPr lvl="0" indent="0" marL="0" algn="l">
+                        <a:buNone/>
+                      </a:pPr>
+                      <a:r>
+                        <a:rPr/>
+                        <a:t>ceiling</a:t>
+                      </a:r>
+                    </a:p>
+                  </a:txBody>
+                </a:tc>
+                <a:tc>
+                  <a:txBody>
+                    <a:bodyPr/>
+                    <a:lstStyle/>
+                    <a:p>
+                      <a:pPr lvl="0" indent="0" marL="0" algn="ctr">
+                        <a:buNone/>
+                      </a:pPr>
+                      <a:r>
+                        <a:rPr/>
+                        <a:t>0.769</a:t>
+                      </a:r>
+                    </a:p>
+                  </a:txBody>
+                </a:tc>
+                <a:tc>
+                  <a:txBody>
+                    <a:bodyPr/>
+                    <a:lstStyle/>
+                    <a:p>
+                      <a:endParaRPr/>
+                    </a:p>
+                  </a:txBody>
+                </a:tc>
+                <a:tc>
+                  <a:txBody>
+                    <a:bodyPr/>
+                    <a:lstStyle/>
+                    <a:p>
+                      <a:pPr lvl="0" indent="0" marL="0" algn="ctr">
+                        <a:buNone/>
+                      </a:pPr>
+                      <a:r>
+                        <a:rPr/>
+                        <a:t>0.797</a:t>
+                      </a:r>
+                    </a:p>
+                  </a:txBody>
+                </a:tc>
+                <a:tc>
+                  <a:txBody>
+                    <a:bodyPr/>
+                    <a:lstStyle/>
+                    <a:p>
+                      <a:endParaRPr/>
+                    </a:p>
+                  </a:txBody>
+                </a:tc>
+              </a:tr>
+            </a:tbl>
+          </a:graphicData>
+        </a:graphic>
+      </p:graphicFrame>
     </p:spTree>
   </p:cSld>
 </p:sld>
 </file>
 
 <file path=ppt/slides/slide15.xml><?xml version="1.0" encoding="utf-8"?>
+<p:sld xmlns:a="http://schemas.openxmlformats.org/drawingml/2006/main" xmlns:r="http://schemas.openxmlformats.org/officeDocument/2006/relationships" xmlns:p="http://schemas.openxmlformats.org/presentationml/2006/main">
+  <p:cSld>
+    <p:spTree>
+      <p:nvGrpSpPr>
+        <p:cNvPr id="1" name=""/>
+        <p:cNvGrpSpPr/>
+        <p:nvPr/>
+      </p:nvGrpSpPr>
+      <p:grpSpPr>
+        <a:xfrm>
+          <a:off x="0" y="0"/>
+          <a:ext cx="0" cy="0"/>
+          <a:chOff x="0" y="0"/>
+          <a:chExt cx="0" cy="0"/>
+        </a:xfrm>
+      </p:grpSpPr>
+      <p:sp>
+        <p:nvSpPr>
+          <p:cNvPr id="2" name="Title 1"/>
+          <p:cNvSpPr>
+            <a:spLocks noGrp="1"/>
+          </p:cNvSpPr>
+          <p:nvPr>
+            <p:ph type="title"/>
+          </p:nvPr>
+        </p:nvSpPr>
+        <p:spPr/>
+        <p:txBody>
+          <a:bodyPr/>
+          <a:lstStyle/>
+          <a:p>
+            <a:pPr lvl="0" indent="0" marL="0">
+              <a:buNone/>
+            </a:pPr>
+            <a:r>
+              <a:rPr/>
+              <a:t>Steps 3 and 4: what they say</a:t>
+            </a:r>
+          </a:p>
+        </p:txBody>
+      </p:sp>
+      <p:sp>
+        <p:nvSpPr>
+          <p:cNvPr id="3" name="Content Placeholder 2"/>
+          <p:cNvSpPr>
+            <a:spLocks noGrp="1"/>
+          </p:cNvSpPr>
+          <p:nvPr>
+            <p:ph idx="1"/>
+          </p:nvPr>
+        </p:nvSpPr>
+        <p:spPr/>
+        <p:txBody>
+          <a:bodyPr/>
+          <a:lstStyle/>
+          <a:p>
+            <a:pPr lvl="0"/>
+            <a:r>
+              <a:rPr b="1"/>
+              <a:t>Step 3 lands below the floor</a:t>
+            </a:r>
+            <a:r>
+              <a:rPr/>
+              <a:t>, and not by noise. Step 1’s answer again on the harder task: a new head on frozen features doesn’t match the published head carried forward</a:t>
+            </a:r>
+          </a:p>
+          <a:p>
+            <a:pPr lvl="0"/>
+            <a:r>
+              <a:rPr b="1"/>
+              <a:t>Step 4 recovers the floor and no more.</a:t>
+            </a:r>
+            <a:r>
+              <a:rPr/>
+              <a:t> Fine-tuning lifts the head by about 0.02 to a tie with the detector at both horizons</a:t>
+            </a:r>
+          </a:p>
+          <a:p>
+            <a:pPr lvl="0"/>
+            <a:r>
+              <a:rPr/>
+              <a:t>Validation was still rising at the epoch cap, so a longer fine-tune might take a little more. The ceiling bounds how much</a:t>
+            </a:r>
+          </a:p>
+          <a:p>
+            <a:pPr lvl="0"/>
+            <a:r>
+              <a:rPr/>
+              <a:t>Same picture in each year: ties the floor in 2015, trails it in 2014</a:t>
+            </a:r>
+          </a:p>
+        </p:txBody>
+      </p:sp>
+    </p:spTree>
+  </p:cSld>
+</p:sld>
+</file>
+
+<file path=ppt/slides/slide16.xml><?xml version="1.0" encoding="utf-8"?>
 <p:sld xmlns:a="http://schemas.openxmlformats.org/drawingml/2006/main" xmlns:r="http://schemas.openxmlformats.org/officeDocument/2006/relationships" xmlns:p="http://schemas.openxmlformats.org/presentationml/2006/main">
   <p:cSld>
     <p:spTree>
@@ -4204,90 +4358,6 @@
 </p:sld>
 </file>
 
-<file path=ppt/slides/slide16.xml><?xml version="1.0" encoding="utf-8"?>
-<p:sld xmlns:a="http://schemas.openxmlformats.org/drawingml/2006/main" xmlns:r="http://schemas.openxmlformats.org/officeDocument/2006/relationships" xmlns:p="http://schemas.openxmlformats.org/presentationml/2006/main">
-  <p:cSld>
-    <p:spTree>
-      <p:nvGrpSpPr>
-        <p:cNvPr id="1" name=""/>
-        <p:cNvGrpSpPr/>
-        <p:nvPr/>
-      </p:nvGrpSpPr>
-      <p:grpSpPr>
-        <a:xfrm>
-          <a:off x="0" y="0"/>
-          <a:ext cx="0" cy="0"/>
-          <a:chOff x="0" y="0"/>
-          <a:chExt cx="0" cy="0"/>
-        </a:xfrm>
-      </p:grpSpPr>
-      <p:sp>
-        <p:nvSpPr>
-          <p:cNvPr id="2" name="Title 1"/>
-          <p:cNvSpPr>
-            <a:spLocks noGrp="1"/>
-          </p:cNvSpPr>
-          <p:nvPr>
-            <p:ph type="title"/>
-          </p:nvPr>
-        </p:nvSpPr>
-        <p:spPr/>
-        <p:txBody>
-          <a:bodyPr/>
-          <a:lstStyle/>
-          <a:p>
-            <a:pPr lvl="0" indent="0" marL="0">
-              <a:buNone/>
-            </a:pPr>
-            <a:r>
-              <a:rPr/>
-              <a:t>The takeaway</a:t>
-            </a:r>
-          </a:p>
-        </p:txBody>
-      </p:sp>
-      <p:sp>
-        <p:nvSpPr>
-          <p:cNvPr id="3" name="Content Placeholder 2"/>
-          <p:cNvSpPr>
-            <a:spLocks noGrp="1"/>
-          </p:cNvSpPr>
-          <p:nvPr>
-            <p:ph idx="1"/>
-          </p:nvPr>
-        </p:nvSpPr>
-        <p:spPr/>
-        <p:txBody>
-          <a:bodyPr/>
-          <a:lstStyle/>
-          <a:p>
-            <a:pPr lvl="0"/>
-            <a:r>
-              <a:rPr/>
-              <a:t>A detector can be pointed at the ten minutes before a tornado, and what it finds there is what it already finds in the latest scan</a:t>
-            </a:r>
-          </a:p>
-          <a:p>
-            <a:pPr lvl="0"/>
-            <a:r>
-              <a:rPr/>
-              <a:t>Its features carry a real early signal, which is why the floor sits at 0.73</a:t>
-            </a:r>
-          </a:p>
-          <a:p>
-            <a:pPr lvl="0"/>
-            <a:r>
-              <a:rPr/>
-              <a:t>Re-reading or fine-tuning them over two scans adds nothing to it, and even a perfect next scan would add only a few hundredths</a:t>
-            </a:r>
-          </a:p>
-        </p:txBody>
-      </p:sp>
-    </p:spTree>
-  </p:cSld>
-</p:sld>
-</file>
-
 <file path=ppt/slides/slide17.xml><?xml version="1.0" encoding="utf-8"?>
 <p:sld xmlns:a="http://schemas.openxmlformats.org/drawingml/2006/main" xmlns:r="http://schemas.openxmlformats.org/officeDocument/2006/relationships" xmlns:p="http://schemas.openxmlformats.org/presentationml/2006/main">
   <p:cSld>
@@ -4325,7 +4395,7 @@
             </a:pPr>
             <a:r>
               <a:rPr/>
-              <a:t>What’s next</a:t>
+              <a:t>The takeaway</a:t>
             </a:r>
           </a:p>
         </p:txBody>
@@ -4347,37 +4417,191 @@
           <a:p>
             <a:pPr lvl="0"/>
             <a:r>
+              <a:rPr/>
+              <a:t>A detector can be pointed at the ten minutes before a tornado, and what it finds there is what it already finds in the latest scan</a:t>
+            </a:r>
+          </a:p>
+          <a:p>
+            <a:pPr lvl="0"/>
+            <a:r>
+              <a:rPr/>
+              <a:t>Its features carry a real early signal, which is why the floor sits at 0.73</a:t>
+            </a:r>
+          </a:p>
+          <a:p>
+            <a:pPr lvl="0"/>
+            <a:r>
+              <a:rPr/>
+              <a:t>Re-reading or fine-tuning them over two scans adds nothing to it, and even a perfect next scan would add only a few hundredths</a:t>
+            </a:r>
+          </a:p>
+        </p:txBody>
+      </p:sp>
+    </p:spTree>
+  </p:cSld>
+</p:sld>
+</file>
+
+<file path=ppt/slides/slide18.xml><?xml version="1.0" encoding="utf-8"?>
+<p:sld xmlns:a="http://schemas.openxmlformats.org/drawingml/2006/main" xmlns:r="http://schemas.openxmlformats.org/officeDocument/2006/relationships" xmlns:p="http://schemas.openxmlformats.org/presentationml/2006/main">
+  <p:cSld>
+    <p:spTree>
+      <p:nvGrpSpPr>
+        <p:cNvPr id="1" name=""/>
+        <p:cNvGrpSpPr/>
+        <p:nvPr/>
+      </p:nvGrpSpPr>
+      <p:grpSpPr>
+        <a:xfrm>
+          <a:off x="0" y="0"/>
+          <a:ext cx="0" cy="0"/>
+          <a:chOff x="0" y="0"/>
+          <a:chExt cx="0" cy="0"/>
+        </a:xfrm>
+      </p:grpSpPr>
+      <p:sp>
+        <p:nvSpPr>
+          <p:cNvPr id="2" name="Title 1"/>
+          <p:cNvSpPr>
+            <a:spLocks noGrp="1"/>
+          </p:cNvSpPr>
+          <p:nvPr>
+            <p:ph type="title"/>
+          </p:nvPr>
+        </p:nvSpPr>
+        <p:spPr/>
+        <p:txBody>
+          <a:bodyPr/>
+          <a:lstStyle/>
+          <a:p>
+            <a:pPr lvl="0" indent="0" marL="0">
+              <a:buNone/>
+            </a:pPr>
+            <a:r>
+              <a:rPr/>
+              <a:t>What’s next: cheap</a:t>
+            </a:r>
+          </a:p>
+        </p:txBody>
+      </p:sp>
+      <p:sp>
+        <p:nvSpPr>
+          <p:cNvPr id="3" name="Content Placeholder 2"/>
+          <p:cNvSpPr>
+            <a:spLocks noGrp="1"/>
+          </p:cNvSpPr>
+          <p:nvPr>
+            <p:ph idx="1"/>
+          </p:nvPr>
+        </p:nvSpPr>
+        <p:spPr/>
+        <p:txBody>
+          <a:bodyPr/>
+          <a:lstStyle/>
+          <a:p>
+            <a:pPr lvl="0"/>
+            <a:r>
+              <a:rPr/>
+              <a:t>The full dataset. Ten years is a config change</a:t>
+            </a:r>
+          </a:p>
+          <a:p>
+            <a:pPr lvl="0"/>
+            <a:r>
+              <a:rPr/>
+              <a:t>It fixes the two things that limited this round: a fine-tune still improving at the cap, and test intervals wide enough to hide a gain of a couple of hundredths</a:t>
+            </a:r>
+          </a:p>
+        </p:txBody>
+      </p:sp>
+    </p:spTree>
+  </p:cSld>
+</p:sld>
+</file>
+
+<file path=ppt/slides/slide19.xml><?xml version="1.0" encoding="utf-8"?>
+<p:sld xmlns:a="http://schemas.openxmlformats.org/drawingml/2006/main" xmlns:r="http://schemas.openxmlformats.org/officeDocument/2006/relationships" xmlns:p="http://schemas.openxmlformats.org/presentationml/2006/main">
+  <p:cSld>
+    <p:spTree>
+      <p:nvGrpSpPr>
+        <p:cNvPr id="1" name=""/>
+        <p:cNvGrpSpPr/>
+        <p:nvPr/>
+      </p:nvGrpSpPr>
+      <p:grpSpPr>
+        <a:xfrm>
+          <a:off x="0" y="0"/>
+          <a:ext cx="0" cy="0"/>
+          <a:chOff x="0" y="0"/>
+          <a:chExt cx="0" cy="0"/>
+        </a:xfrm>
+      </p:grpSpPr>
+      <p:sp>
+        <p:nvSpPr>
+          <p:cNvPr id="2" name="Title 1"/>
+          <p:cNvSpPr>
+            <a:spLocks noGrp="1"/>
+          </p:cNvSpPr>
+          <p:nvPr>
+            <p:ph type="title"/>
+          </p:nvPr>
+        </p:nvSpPr>
+        <p:spPr/>
+        <p:txBody>
+          <a:bodyPr/>
+          <a:lstStyle/>
+          <a:p>
+            <a:pPr lvl="0" indent="0" marL="0">
+              <a:buNone/>
+            </a:pPr>
+            <a:r>
+              <a:rPr/>
+              <a:t>What’s next: larger</a:t>
+            </a:r>
+          </a:p>
+        </p:txBody>
+      </p:sp>
+      <p:sp>
+        <p:nvSpPr>
+          <p:cNvPr id="3" name="Content Placeholder 2"/>
+          <p:cNvSpPr>
+            <a:spLocks noGrp="1"/>
+          </p:cNvSpPr>
+          <p:nvPr>
+            <p:ph idx="1"/>
+          </p:nvPr>
+        </p:nvSpPr>
+        <p:spPr/>
+        <p:txBody>
+          <a:bodyPr/>
+          <a:lstStyle/>
+          <a:p>
+            <a:pPr lvl="0"/>
+            <a:r>
+              <a:rPr/>
+              <a:t>Use the detector for detecting, and build what’s missing around it</a:t>
+            </a:r>
+          </a:p>
+          <a:p>
+            <a:pPr lvl="0"/>
+            <a:r>
               <a:rPr b="1"/>
-              <a:t>Cheap:</a:t>
-            </a:r>
-            <a:r>
-              <a:rPr/>
-              <a:t> the full dataset. Ten years is a config change, and it fixes what limited this round: a fine-tune still improving at the cap, and intervals wide enough to hide a gain of a couple of hundredths</a:t>
+              <a:t>Longer storm histories</a:t>
+            </a:r>
+            <a:r>
+              <a:rPr/>
+              <a:t> than two scans, so a temporal model learns how a storm has been evolving rather than one difference</a:t>
             </a:r>
           </a:p>
           <a:p>
             <a:pPr lvl="0"/>
             <a:r>
               <a:rPr b="1"/>
-              <a:t>Larger:</a:t>
-            </a:r>
-            <a:r>
-              <a:rPr/>
-              <a:t> use the detector for detecting, and build what’s missing around it</a:t>
-            </a:r>
-          </a:p>
-          <a:p>
-            <a:pPr lvl="1"/>
-            <a:r>
-              <a:rPr/>
-              <a:t>longer storm histories than two scans, so a temporal model learns how a storm has been evolving rather than one difference</a:t>
-            </a:r>
-          </a:p>
-          <a:p>
-            <a:pPr lvl="1"/>
-            <a:r>
-              <a:rPr/>
-              <a:t>a forecasting model that learns those patterns and does two jobs: hands the detector the context one scan leaves out, and predicts the radar itself so the detector reads a forecast scan</a:t>
+              <a:t>A forecasting model</a:t>
+            </a:r>
+            <a:r>
+              <a:rPr/>
+              <a:t> that learns those patterns and does two jobs: hands the detector the context one scan leaves out, and predicts the radar itself, so the detector reads a forecast scan</a:t>
             </a:r>
           </a:p>
           <a:p>
@@ -4492,7 +4716,7 @@
             </a:r>
             <a:r>
               <a:rPr/>
-              <a:t>: given the two oldest of a sample’s four scans, how likely is a tornado in each of the two newest, roughly +5 and +10 minutes out?</a:t>
+              <a:t>: given the two oldest of a sample’s four scans, how likely is a tornado in each of the two newest, about +5 and +10 minutes out?</a:t>
             </a:r>
           </a:p>
         </p:txBody>
@@ -4539,7 +4763,7 @@
             </a:pPr>
             <a:r>
               <a:rPr/>
-              <a:t>Keeping it honest</a:t>
+              <a:t>Keeping it honest: what gets scored</a:t>
             </a:r>
           </a:p>
         </p:txBody>
@@ -4562,7 +4786,14 @@
             <a:pPr lvl="0"/>
             <a:r>
               <a:rPr/>
-              <a:t>A tornado already on the radar is trivial to carry forward, so we score only </a:t>
+              <a:t>A tornado already on the radar is trivial to carry forward</a:t>
+            </a:r>
+          </a:p>
+          <a:p>
+            <a:pPr lvl="0"/>
+            <a:r>
+              <a:rPr/>
+              <a:t>So we score only </a:t>
             </a:r>
             <a:r>
               <a:rPr b="1"/>
@@ -4570,7 +4801,7 @@
             </a:r>
             <a:r>
               <a:rPr/>
-              <a:t> cases: nothing tornadic in the input scans, tornado present in the last target scan</a:t>
+              <a:t> cases: nothing tornadic in the input scans, a tornado in the last target scan</a:t>
             </a:r>
           </a:p>
           <a:p>
@@ -4586,42 +4817,6 @@
             <a:r>
               <a:rPr/>
               <a:t> that never produced one</a:t>
-            </a:r>
-          </a:p>
-          <a:p>
-            <a:pPr lvl="0"/>
-            <a:r>
-              <a:rPr/>
-              <a:t>Two reference points from the published detector itself, frozen:</a:t>
-            </a:r>
-          </a:p>
-          <a:p>
-            <a:pPr lvl="1"/>
-            <a:r>
-              <a:rPr b="1"/>
-              <a:t>floor</a:t>
-            </a:r>
-            <a:r>
-              <a:rPr/>
-              <a:t>: the detector on the newest observed scan, what a forecaster already has</a:t>
-            </a:r>
-          </a:p>
-          <a:p>
-            <a:pPr lvl="1"/>
-            <a:r>
-              <a:rPr b="1"/>
-              <a:t>ceiling</a:t>
-            </a:r>
-            <a:r>
-              <a:rPr/>
-              <a:t>: the detector on the real future scan, what detection gives if the radar forecast were perfect</a:t>
-            </a:r>
-          </a:p>
-          <a:p>
-            <a:pPr lvl="0"/>
-            <a:r>
-              <a:rPr/>
-              <a:t>A model lands somewhere between; the result is its paired difference from the floor on the same files</a:t>
             </a:r>
           </a:p>
         </p:txBody>
@@ -4668,7 +4863,7 @@
             </a:pPr>
             <a:r>
               <a:rPr/>
-              <a:t>The data</a:t>
+              <a:t>Keeping it honest: floor and ceiling</a:t>
             </a:r>
           </a:p>
         </p:txBody>
@@ -4691,50 +4886,36 @@
             <a:pPr lvl="0"/>
             <a:r>
               <a:rPr/>
-              <a:t>TorNet v1.1: 203,133 samples, 2013 to 2022, four NEXRAD dual-pol scans per sample about five minutes apart, six products at two tilts, a label per scan</a:t>
+              <a:t>Both come from the published detector itself, frozen, as released</a:t>
             </a:r>
           </a:p>
           <a:p>
             <a:pPr lvl="0"/>
             <a:r>
-              <a:rPr/>
-              <a:t>Repackaged on the Hugging Face Hub as Parquet by year, with the detector’s weights as a PyTorch state dict next to it, so a run needs nothing downloaded by hand</a:t>
+              <a:rPr b="1"/>
+              <a:t>Floor</a:t>
+            </a:r>
+            <a:r>
+              <a:rPr/>
+              <a:t>: the detector on the newest observed scan. What a forecaster already has</a:t>
             </a:r>
           </a:p>
           <a:p>
             <a:pPr lvl="0"/>
             <a:r>
-              <a:rPr/>
-              <a:t>This round: </a:t>
-            </a:r>
-            <a:r>
               <a:rPr b="1"/>
-              <a:t>2014 and 2015</a:t>
-            </a:r>
-            <a:r>
-              <a:rPr/>
-              <a:t>, cut two ways</a:t>
-            </a:r>
-          </a:p>
-          <a:p>
-            <a:pPr lvl="1"/>
-            <a:r>
-              <a:rPr/>
-              <a:t>detection steps: 6,414 clips split by storm group, 1,422 test with 89 positives</a:t>
-            </a:r>
-          </a:p>
-          <a:p>
-            <a:pPr lvl="1"/>
-            <a:r>
-              <a:rPr/>
-              <a:t>onset steps: the authors’ partitions, 37,168 train, 6,448 test with 495 pre-onset cases</a:t>
+              <a:t>Ceiling</a:t>
+            </a:r>
+            <a:r>
+              <a:rPr/>
+              <a:t>: the detector on the real future scan. What detection gives if the radar forecast were perfect</a:t>
             </a:r>
           </a:p>
           <a:p>
             <a:pPr lvl="0"/>
             <a:r>
               <a:rPr/>
-              <a:t>Every model sees a scan exactly as the published detector does, so its weights drop in with no adapter</a:t>
+              <a:t>A model lands somewhere between. The result is its paired difference from the floor on the same test files, with a 95% interval</a:t>
             </a:r>
           </a:p>
         </p:txBody>
@@ -4781,7 +4962,7 @@
             </a:pPr>
             <a:r>
               <a:rPr/>
-              <a:t>The models</a:t>
+              <a:t>The data</a:t>
             </a:r>
           </a:p>
         </p:txBody>
@@ -4801,12 +4982,46 @@
           <a:bodyPr/>
           <a:lstStyle/>
           <a:p>
-            <a:pPr lvl="0" indent="0" marL="0">
-              <a:buNone/>
-            </a:pPr>
-            <a:r>
-              <a:rPr/>
-              <a:t>Both start from the published CNN: four CoordConv blocks ending in a 384-channel map over an 8 × 15 grid.</a:t>
+            <a:pPr lvl="0"/>
+            <a:r>
+              <a:rPr/>
+              <a:t>TorNet v1.1: 203,133 samples, 2013 to 2022. Four NEXRAD dual-pol scans per sample about five minutes apart, six products at two tilts, a label per scan</a:t>
+            </a:r>
+          </a:p>
+          <a:p>
+            <a:pPr lvl="0"/>
+            <a:r>
+              <a:rPr/>
+              <a:t>Repackaged on the Hugging Face Hub as Parquet by year, detector weights alongside: nothing to download by hand</a:t>
+            </a:r>
+          </a:p>
+          <a:p>
+            <a:pPr lvl="0"/>
+            <a:r>
+              <a:rPr/>
+              <a:t>This round is </a:t>
+            </a:r>
+            <a:r>
+              <a:rPr b="1"/>
+              <a:t>2014 and 2015</a:t>
+            </a:r>
+            <a:r>
+              <a:rPr/>
+              <a:t>, cut two ways</a:t>
+            </a:r>
+          </a:p>
+          <a:p>
+            <a:pPr lvl="1"/>
+            <a:r>
+              <a:rPr/>
+              <a:t>detection steps: 6,414 clips split by storm group, 1,422 test with 89 positives</a:t>
+            </a:r>
+          </a:p>
+          <a:p>
+            <a:pPr lvl="1"/>
+            <a:r>
+              <a:rPr/>
+              <a:t>onset steps: the authors’ partitions, 37,168 train, 6,448 test with 495 pre-onset cases</a:t>
             </a:r>
           </a:p>
         </p:txBody>
@@ -4835,106 +5050,84 @@
       </p:grpSpPr>
       <p:sp>
         <p:nvSpPr>
+          <p:cNvPr id="2" name="Title 1"/>
+          <p:cNvSpPr>
+            <a:spLocks noGrp="1"/>
+          </p:cNvSpPr>
+          <p:nvPr>
+            <p:ph type="title"/>
+          </p:nvPr>
+        </p:nvSpPr>
+        <p:spPr/>
+        <p:txBody>
+          <a:bodyPr/>
+          <a:lstStyle/>
+          <a:p>
+            <a:pPr lvl="0" indent="0" marL="0">
+              <a:buNone/>
+            </a:pPr>
+            <a:r>
+              <a:rPr/>
+              <a:t>Model A: frozen features, small head</a:t>
+            </a:r>
+          </a:p>
+        </p:txBody>
+      </p:sp>
+      <p:sp>
+        <p:nvSpPr>
           <p:cNvPr id="3" name="Content Placeholder 2"/>
           <p:cNvSpPr>
             <a:spLocks noGrp="1"/>
           </p:cNvSpPr>
           <p:nvPr>
-            <p:ph idx="1" sz="half"/>
-          </p:nvPr>
-        </p:nvSpPr>
-        <p:spPr/>
-        <p:txBody>
-          <a:bodyPr/>
-          <a:lstStyle/>
-          <a:p>
-            <a:pPr lvl="0" indent="0" marL="0">
-              <a:buNone/>
-            </a:pPr>
+            <p:ph idx="1"/>
+          </p:nvPr>
+        </p:nvSpPr>
+        <p:spPr/>
+        <p:txBody>
+          <a:bodyPr/>
+          <a:lstStyle/>
+          <a:p>
+            <a:pPr lvl="0"/>
+            <a:r>
+              <a:rPr/>
+              <a:t>The published CNN, frozen: four CoordConv blocks ending in a 384-channel map over an 8 × 15 grid</a:t>
+            </a:r>
+          </a:p>
+          <a:p>
+            <a:pPr lvl="0"/>
+            <a:r>
+              <a:rPr/>
+              <a:t>Each scan reduced to its 384 pooled features, scaled, read by a 385-parameter linear head</a:t>
+            </a:r>
+          </a:p>
+          <a:p>
+            <a:pPr lvl="0"/>
+            <a:r>
+              <a:rPr/>
+              <a:t>Target: tornado presence in the </a:t>
+            </a:r>
             <a:r>
               <a:rPr b="1"/>
-              <a:t>Frozen features, small head</a:t>
+              <a:t>current</a:t>
+            </a:r>
+            <a:r>
+              <a:rPr/>
+              <a:t> scan</a:t>
             </a:r>
           </a:p>
           <a:p>
             <a:pPr lvl="0"/>
             <a:r>
               <a:rPr/>
-              <a:t>CNN frozen, 384 pooled features per scan</a:t>
+              <a:t>With two scans, the current and the one five minutes earlier, the feature vectors are averaged</a:t>
             </a:r>
           </a:p>
           <a:p>
             <a:pPr lvl="0"/>
             <a:r>
               <a:rPr/>
-              <a:t>385-parameter linear head, current-scan label</a:t>
-            </a:r>
-          </a:p>
-          <a:p>
-            <a:pPr lvl="0"/>
-            <a:r>
-              <a:rPr/>
-              <a:t>two scans: feature vectors averaged</a:t>
-            </a:r>
-          </a:p>
-          <a:p>
-            <a:pPr lvl="0"/>
-            <a:r>
-              <a:rPr/>
-              <a:t>three seeds, validation picks everything, test touched once</a:t>
-            </a:r>
-          </a:p>
-        </p:txBody>
-      </p:sp>
-      <p:sp>
-        <p:nvSpPr>
-          <p:cNvPr id="4" name="Content Placeholder 3"/>
-          <p:cNvSpPr>
-            <a:spLocks noGrp="1"/>
-          </p:cNvSpPr>
-          <p:nvPr>
-            <p:ph idx="2" sz="half"/>
-          </p:nvPr>
-        </p:nvSpPr>
-        <p:spPr/>
-        <p:txBody>
-          <a:bodyPr/>
-          <a:lstStyle/>
-          <a:p>
-            <a:pPr lvl="0" indent="0" marL="0">
-              <a:buNone/>
-            </a:pPr>
-            <a:r>
-              <a:rPr b="1"/>
-              <a:t>Two scans, the authors’ head, onset target</a:t>
-            </a:r>
-          </a:p>
-          <a:p>
-            <a:pPr lvl="0"/>
-            <a:r>
-              <a:rPr/>
-              <a:t>CNN on both scans, maps concatenated cell by cell (768 channels)</a:t>
-            </a:r>
-          </a:p>
-          <a:p>
-            <a:pPr lvl="0"/>
-            <a:r>
-              <a:rPr/>
-              <a:t>a fresh copy of the authors’ head: 1×1 convs to a per-cell logit, max over cells</a:t>
-            </a:r>
-          </a:p>
-          <a:p>
-            <a:pPr lvl="0"/>
-            <a:r>
-              <a:rPr/>
-              <a:t>one logit per horizon, weighted BCE against the future labels</a:t>
-            </a:r>
-          </a:p>
-          <a:p>
-            <a:pPr lvl="0"/>
-            <a:r>
-              <a:rPr/>
-              <a:t>CNN frozen in one run, fine-tuned at a tenth of the head’s learning rate in the other</a:t>
+              <a:t>Three seeds, validation picks the epoch and threshold, test touched once</a:t>
             </a:r>
           </a:p>
         </p:txBody>
@@ -4971,12 +5164,7 @@
             <p:ph type="title"/>
           </p:nvPr>
         </p:nvSpPr>
-        <p:spPr>
-          <a:xfrm>
-            <a:off x="457201" y="204787"/>
-            <a:ext cx="3008313" cy="871538"/>
-          </a:xfrm>
-        </p:spPr>
+        <p:spPr/>
         <p:txBody>
           <a:bodyPr/>
           <a:lstStyle/>
@@ -4986,350 +5174,70 @@
             </a:pPr>
             <a:r>
               <a:rPr/>
-              <a:t>The ladder</a:t>
-            </a:r>
-          </a:p>
-        </p:txBody>
-      </p:sp>
-      <p:sp>
-        <p:nvSpPr>
-          <p:cNvPr id="4" name="Text Placeholder 3"/>
-          <p:cNvSpPr>
-            <a:spLocks noGrp="1"/>
-          </p:cNvSpPr>
-          <p:nvPr>
-            <p:ph idx="2" sz="half" type="body"/>
-          </p:nvPr>
-        </p:nvSpPr>
-        <p:spPr/>
-        <p:txBody>
-          <a:bodyPr/>
-          <a:lstStyle/>
-          <a:p>
-            <a:pPr lvl="0" indent="0" marL="0">
-              <a:buNone/>
-            </a:pPr>
-            <a:r>
-              <a:rPr/>
-              <a:t>Five steps, each changing one thing. The first two stay on the detection task to check the ingredients before the task changes.</a:t>
-            </a:r>
-          </a:p>
-        </p:txBody>
-      </p:sp>
-      <p:graphicFrame>
-        <p:nvGraphicFramePr>
-          <p:cNvPr id="6" name="Content Placeholder 5"/>
-          <p:cNvGraphicFramePr>
-            <a:graphicFrameLocks noGrp="1"/>
-          </p:cNvGraphicFramePr>
+              <a:t>Model B: two scans, the authors’ head, onset target</a:t>
+            </a:r>
+          </a:p>
+        </p:txBody>
+      </p:sp>
+      <p:sp>
+        <p:nvSpPr>
+          <p:cNvPr id="3" name="Content Placeholder 2"/>
+          <p:cNvSpPr>
+            <a:spLocks noGrp="1"/>
+          </p:cNvSpPr>
           <p:nvPr>
             <p:ph idx="1"/>
           </p:nvPr>
-        </p:nvGraphicFramePr>
-        <p:xfrm>
-          <a:off x="3568700" y="203200"/>
-          <a:ext cx="5105400" cy="4381500"/>
-        </p:xfrm>
-        <a:graphic>
-          <a:graphicData uri="http://schemas.openxmlformats.org/drawingml/2006/table">
-            <a:tbl>
-              <a:tblPr firstRow="1" bandRow="1">
-                <a:tableStyleId>{5C22544A-7EE6-4342-B048-85BDC9FD1C3A}</a:tableStyleId>
-              </a:tblPr>
-              <a:tblGrid>
-                <a:gridCol w="2044700"/>
-                <a:gridCol w="1536700"/>
-                <a:gridCol w="1536700"/>
-              </a:tblGrid>
-              <a:tr h="0">
-                <a:tc>
-                  <a:txBody>
-                    <a:bodyPr/>
-                    <a:lstStyle/>
-                    <a:p>
-                      <a:pPr lvl="0" indent="0" marL="0" algn="ctr">
-                        <a:buNone/>
-                      </a:pPr>
-                      <a:r>
-                        <a:rPr/>
-                        <a:t>step</a:t>
-                      </a:r>
-                    </a:p>
-                  </a:txBody>
-                  <a:tcPr/>
-                </a:tc>
-                <a:tc>
-                  <a:txBody>
-                    <a:bodyPr/>
-                    <a:lstStyle/>
-                    <a:p>
-                      <a:pPr lvl="0" indent="0" marL="0" algn="l">
-                        <a:buNone/>
-                      </a:pPr>
-                      <a:r>
-                        <a:rPr/>
-                        <a:t>what changes</a:t>
-                      </a:r>
-                    </a:p>
-                  </a:txBody>
-                  <a:tcPr/>
-                </a:tc>
-                <a:tc>
-                  <a:txBody>
-                    <a:bodyPr/>
-                    <a:lstStyle/>
-                    <a:p>
-                      <a:pPr lvl="0" indent="0" marL="0" algn="l">
-                        <a:buNone/>
-                      </a:pPr>
-                      <a:r>
-                        <a:rPr/>
-                        <a:t>question</a:t>
-                      </a:r>
-                    </a:p>
-                  </a:txBody>
-                  <a:tcPr/>
-                </a:tc>
-              </a:tr>
-              <a:tr h="0">
-                <a:tc>
-                  <a:txBody>
-                    <a:bodyPr/>
-                    <a:lstStyle/>
-                    <a:p>
-                      <a:pPr lvl="0" indent="0" marL="0" algn="ctr">
-                        <a:buNone/>
-                      </a:pPr>
-                      <a:r>
-                        <a:rPr/>
-                        <a:t>0</a:t>
-                      </a:r>
-                    </a:p>
-                  </a:txBody>
-                </a:tc>
-                <a:tc>
-                  <a:txBody>
-                    <a:bodyPr/>
-                    <a:lstStyle/>
-                    <a:p>
-                      <a:pPr lvl="0" indent="0" marL="0" algn="l">
-                        <a:buNone/>
-                      </a:pPr>
-                      <a:r>
-                        <a:rPr/>
-                        <a:t>nothing trained: the published detector, one scan</a:t>
-                      </a:r>
-                    </a:p>
-                  </a:txBody>
-                </a:tc>
-                <a:tc>
-                  <a:txBody>
-                    <a:bodyPr/>
-                    <a:lstStyle/>
-                    <a:p>
-                      <a:pPr lvl="0" indent="0" marL="0" algn="l">
-                        <a:buNone/>
-                      </a:pPr>
-                      <a:r>
-                        <a:rPr/>
-                        <a:t>what does it already give?</a:t>
-                      </a:r>
-                    </a:p>
-                  </a:txBody>
-                </a:tc>
-              </a:tr>
-              <a:tr h="0">
-                <a:tc>
-                  <a:txBody>
-                    <a:bodyPr/>
-                    <a:lstStyle/>
-                    <a:p>
-                      <a:pPr lvl="0" indent="0" marL="0" algn="ctr">
-                        <a:buNone/>
-                      </a:pPr>
-                      <a:r>
-                        <a:rPr/>
-                        <a:t>1</a:t>
-                      </a:r>
-                    </a:p>
-                  </a:txBody>
-                </a:tc>
-                <a:tc>
-                  <a:txBody>
-                    <a:bodyPr/>
-                    <a:lstStyle/>
-                    <a:p>
-                      <a:pPr lvl="0" indent="0" marL="0" algn="l">
-                        <a:buNone/>
-                      </a:pPr>
-                      <a:r>
-                        <a:rPr/>
-                        <a:t>new linear head on frozen features, current scan</a:t>
-                      </a:r>
-                    </a:p>
-                  </a:txBody>
-                </a:tc>
-                <a:tc>
-                  <a:txBody>
-                    <a:bodyPr/>
-                    <a:lstStyle/>
-                    <a:p>
-                      <a:pPr lvl="0" indent="0" marL="0" algn="l">
-                        <a:buNone/>
-                      </a:pPr>
-                      <a:r>
-                        <a:rPr/>
-                        <a:t>can a retrained head beat the detector at its own job?</a:t>
-                      </a:r>
-                    </a:p>
-                  </a:txBody>
-                </a:tc>
-              </a:tr>
-              <a:tr h="0">
-                <a:tc>
-                  <a:txBody>
-                    <a:bodyPr/>
-                    <a:lstStyle/>
-                    <a:p>
-                      <a:pPr lvl="0" indent="0" marL="0" algn="ctr">
-                        <a:buNone/>
-                      </a:pPr>
-                      <a:r>
-                        <a:rPr/>
-                        <a:t>2</a:t>
-                      </a:r>
-                    </a:p>
-                  </a:txBody>
-                </a:tc>
-                <a:tc>
-                  <a:txBody>
-                    <a:bodyPr/>
-                    <a:lstStyle/>
-                    <a:p>
-                      <a:pPr lvl="0" indent="0" marL="0" algn="l">
-                        <a:buNone/>
-                      </a:pPr>
-                      <a:r>
-                        <a:rPr/>
-                        <a:t>the scan five minutes earlier added, features averaged</a:t>
-                      </a:r>
-                    </a:p>
-                  </a:txBody>
-                </a:tc>
-                <a:tc>
-                  <a:txBody>
-                    <a:bodyPr/>
-                    <a:lstStyle/>
-                    <a:p>
-                      <a:pPr lvl="0" indent="0" marL="0" algn="l">
-                        <a:buNone/>
-                      </a:pPr>
-                      <a:r>
-                        <a:rPr/>
-                        <a:t>does a second scan carry anything the first doesn’t?</a:t>
-                      </a:r>
-                    </a:p>
-                  </a:txBody>
-                </a:tc>
-              </a:tr>
-              <a:tr h="0">
-                <a:tc>
-                  <a:txBody>
-                    <a:bodyPr/>
-                    <a:lstStyle/>
-                    <a:p>
-                      <a:pPr lvl="0" indent="0" marL="0" algn="ctr">
-                        <a:buNone/>
-                      </a:pPr>
-                      <a:r>
-                        <a:rPr/>
-                        <a:t>3</a:t>
-                      </a:r>
-                    </a:p>
-                  </a:txBody>
-                </a:tc>
-                <a:tc>
-                  <a:txBody>
-                    <a:bodyPr/>
-                    <a:lstStyle/>
-                    <a:p>
-                      <a:pPr lvl="0" indent="0" marL="0" algn="l">
-                        <a:buNone/>
-                      </a:pPr>
-                      <a:r>
-                        <a:rPr/>
-                        <a:t>frozen CNN, both scans, the authors’ head retrained on +5 / +10 labels</a:t>
-                      </a:r>
-                    </a:p>
-                  </a:txBody>
-                </a:tc>
-                <a:tc>
-                  <a:txBody>
-                    <a:bodyPr/>
-                    <a:lstStyle/>
-                    <a:p>
-                      <a:pPr lvl="0" indent="0" marL="0" algn="l">
-                        <a:buNone/>
-                      </a:pPr>
-                      <a:r>
-                        <a:rPr/>
-                        <a:t>can the features be re-aimed at “will it appear”?</a:t>
-                      </a:r>
-                    </a:p>
-                  </a:txBody>
-                </a:tc>
-              </a:tr>
-              <a:tr h="0">
-                <a:tc>
-                  <a:txBody>
-                    <a:bodyPr/>
-                    <a:lstStyle/>
-                    <a:p>
-                      <a:pPr lvl="0" indent="0" marL="0" algn="ctr">
-                        <a:buNone/>
-                      </a:pPr>
-                      <a:r>
-                        <a:rPr/>
-                        <a:t>4</a:t>
-                      </a:r>
-                    </a:p>
-                  </a:txBody>
-                </a:tc>
-                <a:tc>
-                  <a:txBody>
-                    <a:bodyPr/>
-                    <a:lstStyle/>
-                    <a:p>
-                      <a:pPr lvl="0" indent="0" marL="0" algn="l">
-                        <a:buNone/>
-                      </a:pPr>
-                      <a:r>
-                        <a:rPr/>
-                        <a:t>the CNN unfrozen</a:t>
-                      </a:r>
-                    </a:p>
-                  </a:txBody>
-                </a:tc>
-                <a:tc>
-                  <a:txBody>
-                    <a:bodyPr/>
-                    <a:lstStyle/>
-                    <a:p>
-                      <a:pPr lvl="0" indent="0" marL="0" algn="l">
-                        <a:buNone/>
-                      </a:pPr>
-                      <a:r>
-                        <a:rPr/>
-                        <a:t>does adapting the features buy more?</a:t>
-                      </a:r>
-                    </a:p>
-                  </a:txBody>
-                </a:tc>
-              </a:tr>
-            </a:tbl>
-          </a:graphicData>
-        </a:graphic>
-      </p:graphicFrame>
+        </p:nvSpPr>
+        <p:spPr/>
+        <p:txBody>
+          <a:bodyPr/>
+          <a:lstStyle/>
+          <a:p>
+            <a:pPr lvl="0"/>
+            <a:r>
+              <a:rPr/>
+              <a:t>The same CNN run on both input scans, the two maps concatenated cell by cell into 768 channels</a:t>
+            </a:r>
+          </a:p>
+          <a:p>
+            <a:pPr lvl="0"/>
+            <a:r>
+              <a:rPr/>
+              <a:t>On top, a fresh copy of the authors’ own head: 1×1 convs to a per-cell logit, max over cells</a:t>
+            </a:r>
+          </a:p>
+          <a:p>
+            <a:pPr lvl="0"/>
+            <a:r>
+              <a:rPr/>
+              <a:t>One logit per horizon, weighted cross-entropy against the </a:t>
+            </a:r>
+            <a:r>
+              <a:rPr b="1"/>
+              <a:t>future</a:t>
+            </a:r>
+            <a:r>
+              <a:rPr/>
+              <a:t> scans’ labels</a:t>
+            </a:r>
+          </a:p>
+          <a:p>
+            <a:pPr lvl="0"/>
+            <a:r>
+              <a:rPr/>
+              <a:t>CNN frozen in one run, fine-tuned at a tenth of the head’s learning rate in the other</a:t>
+            </a:r>
+          </a:p>
+          <a:p>
+            <a:pPr lvl="0"/>
+            <a:r>
+              <a:rPr/>
+              <a:t>Early stopping on validation AUC, cap of five epochs</a:t>
+            </a:r>
+          </a:p>
+        </p:txBody>
+      </p:sp>
     </p:spTree>
   </p:cSld>
 </p:sld>
@@ -5372,7 +5280,7 @@
             </a:pPr>
             <a:r>
               <a:rPr/>
-              <a:t>Steps 1 and 2: the detection task</a:t>
+              <a:t>The ladder: five steps, one change each</a:t>
             </a:r>
           </a:p>
         </p:txBody>
@@ -5398,10 +5306,9 @@
                 <a:tableStyleId>{5C22544A-7EE6-4342-B048-85BDC9FD1C3A}</a:tableStyleId>
               </a:tblPr>
               <a:tblGrid>
-                <a:gridCol w="1765300"/>
-                <a:gridCol w="2349500"/>
-                <a:gridCol w="2349500"/>
-                <a:gridCol w="1765300"/>
+                <a:gridCol w="3289300"/>
+                <a:gridCol w="2463800"/>
+                <a:gridCol w="2463800"/>
               </a:tblGrid>
               <a:tr h="0">
                 <a:tc>
@@ -5409,12 +5316,28 @@
                     <a:bodyPr/>
                     <a:lstStyle/>
                     <a:p>
+                      <a:pPr lvl="0" indent="0" marL="0" algn="ctr">
+                        <a:buNone/>
+                      </a:pPr>
+                      <a:r>
+                        <a:rPr/>
+                        <a:t>step</a:t>
+                      </a:r>
+                    </a:p>
+                  </a:txBody>
+                  <a:tcPr/>
+                </a:tc>
+                <a:tc>
+                  <a:txBody>
+                    <a:bodyPr/>
+                    <a:lstStyle/>
+                    <a:p>
                       <a:pPr lvl="0" indent="0" marL="0" algn="l">
                         <a:buNone/>
                       </a:pPr>
                       <a:r>
                         <a:rPr/>
-                        <a:t>configuration</a:t>
+                        <a:t>what changes</a:t>
                       </a:r>
                     </a:p>
                   </a:txBody>
@@ -5425,44 +5348,12 @@
                     <a:bodyPr/>
                     <a:lstStyle/>
                     <a:p>
-                      <a:pPr lvl="0" indent="0" marL="0" algn="ctr">
-                        <a:buNone/>
-                      </a:pPr>
-                      <a:r>
-                        <a:rPr/>
-                        <a:t>validation AP</a:t>
-                      </a:r>
-                    </a:p>
-                  </a:txBody>
-                  <a:tcPr/>
-                </a:tc>
-                <a:tc>
-                  <a:txBody>
-                    <a:bodyPr/>
-                    <a:lstStyle/>
-                    <a:p>
-                      <a:pPr lvl="0" indent="0" marL="0" algn="ctr">
-                        <a:buNone/>
-                      </a:pPr>
-                      <a:r>
-                        <a:rPr/>
-                        <a:t>test AP</a:t>
-                      </a:r>
-                    </a:p>
-                  </a:txBody>
-                  <a:tcPr/>
-                </a:tc>
-                <a:tc>
-                  <a:txBody>
-                    <a:bodyPr/>
-                    <a:lstStyle/>
-                    <a:p>
                       <a:pPr lvl="0" indent="0" marL="0" algn="l">
                         <a:buNone/>
                       </a:pPr>
                       <a:r>
                         <a:rPr/>
-                        <a:t>at the locked threshold</a:t>
+                        <a:t>question</a:t>
                       </a:r>
                     </a:p>
                   </a:txBody>
@@ -5475,36 +5366,27 @@
                     <a:bodyPr/>
                     <a:lstStyle/>
                     <a:p>
+                      <a:pPr lvl="0" indent="0" marL="0" algn="ctr">
+                        <a:buNone/>
+                      </a:pPr>
+                      <a:r>
+                        <a:rPr/>
+                        <a:t>0</a:t>
+                      </a:r>
+                    </a:p>
+                  </a:txBody>
+                </a:tc>
+                <a:tc>
+                  <a:txBody>
+                    <a:bodyPr/>
+                    <a:lstStyle/>
+                    <a:p>
                       <a:pPr lvl="0" indent="0" marL="0" algn="l">
                         <a:buNone/>
                       </a:pPr>
                       <a:r>
                         <a:rPr/>
-                        <a:t>original pretrained CNN</a:t>
-                      </a:r>
-                    </a:p>
-                  </a:txBody>
-                </a:tc>
-                <a:tc>
-                  <a:txBody>
-                    <a:bodyPr/>
-                    <a:lstStyle/>
-                    <a:p>
-                      <a:endParaRPr/>
-                    </a:p>
-                  </a:txBody>
-                </a:tc>
-                <a:tc>
-                  <a:txBody>
-                    <a:bodyPr/>
-                    <a:lstStyle/>
-                    <a:p>
-                      <a:pPr lvl="0" indent="0" marL="0" algn="ctr">
-                        <a:buNone/>
-                      </a:pPr>
-                      <a:r>
-                        <a:rPr/>
-                        <a:t>0.517</a:t>
+                        <a:t>nothing trained: the published detector, one scan</a:t>
                       </a:r>
                     </a:p>
                   </a:txBody>
@@ -5519,7 +5401,7 @@
                       </a:pPr>
                       <a:r>
                         <a:rPr/>
-                        <a:t>68 of 89 found, 276 false alarms</a:t>
+                        <a:t>what does it already give?</a:t>
                       </a:r>
                     </a:p>
                   </a:txBody>
@@ -5531,42 +5413,27 @@
                     <a:bodyPr/>
                     <a:lstStyle/>
                     <a:p>
+                      <a:pPr lvl="0" indent="0" marL="0" algn="ctr">
+                        <a:buNone/>
+                      </a:pPr>
+                      <a:r>
+                        <a:rPr/>
+                        <a:t>1</a:t>
+                      </a:r>
+                    </a:p>
+                  </a:txBody>
+                </a:tc>
+                <a:tc>
+                  <a:txBody>
+                    <a:bodyPr/>
+                    <a:lstStyle/>
+                    <a:p>
                       <a:pPr lvl="0" indent="0" marL="0" algn="l">
                         <a:buNone/>
                       </a:pPr>
                       <a:r>
                         <a:rPr/>
-                        <a:t>step 1: current scan, linear head</a:t>
-                      </a:r>
-                    </a:p>
-                  </a:txBody>
-                </a:tc>
-                <a:tc>
-                  <a:txBody>
-                    <a:bodyPr/>
-                    <a:lstStyle/>
-                    <a:p>
-                      <a:pPr lvl="0" indent="0" marL="0" algn="ctr">
-                        <a:buNone/>
-                      </a:pPr>
-                      <a:r>
-                        <a:rPr/>
-                        <a:t>0.658</a:t>
-                      </a:r>
-                    </a:p>
-                  </a:txBody>
-                </a:tc>
-                <a:tc>
-                  <a:txBody>
-                    <a:bodyPr/>
-                    <a:lstStyle/>
-                    <a:p>
-                      <a:pPr lvl="0" indent="0" marL="0" algn="ctr">
-                        <a:buNone/>
-                      </a:pPr>
-                      <a:r>
-                        <a:rPr/>
-                        <a:t>0.508</a:t>
+                        <a:t>new linear head on frozen features, current scan</a:t>
                       </a:r>
                     </a:p>
                   </a:txBody>
@@ -5581,7 +5448,7 @@
                       </a:pPr>
                       <a:r>
                         <a:rPr/>
-                        <a:t>70 found, 571 false alarms</a:t>
+                        <a:t>can a retrained head beat the detector at its own job?</a:t>
                       </a:r>
                     </a:p>
                   </a:txBody>
@@ -5593,42 +5460,27 @@
                     <a:bodyPr/>
                     <a:lstStyle/>
                     <a:p>
+                      <a:pPr lvl="0" indent="0" marL="0" algn="ctr">
+                        <a:buNone/>
+                      </a:pPr>
+                      <a:r>
+                        <a:rPr/>
+                        <a:t>2</a:t>
+                      </a:r>
+                    </a:p>
+                  </a:txBody>
+                </a:tc>
+                <a:tc>
+                  <a:txBody>
+                    <a:bodyPr/>
+                    <a:lstStyle/>
+                    <a:p>
                       <a:pPr lvl="0" indent="0" marL="0" algn="l">
                         <a:buNone/>
                       </a:pPr>
                       <a:r>
                         <a:rPr/>
-                        <a:t>step 2: two-scan mean, linear head</a:t>
-                      </a:r>
-                    </a:p>
-                  </a:txBody>
-                </a:tc>
-                <a:tc>
-                  <a:txBody>
-                    <a:bodyPr/>
-                    <a:lstStyle/>
-                    <a:p>
-                      <a:pPr lvl="0" indent="0" marL="0" algn="ctr">
-                        <a:buNone/>
-                      </a:pPr>
-                      <a:r>
-                        <a:rPr b="1"/>
-                        <a:t>0.675</a:t>
-                      </a:r>
-                    </a:p>
-                  </a:txBody>
-                </a:tc>
-                <a:tc>
-                  <a:txBody>
-                    <a:bodyPr/>
-                    <a:lstStyle/>
-                    <a:p>
-                      <a:pPr lvl="0" indent="0" marL="0" algn="ctr">
-                        <a:buNone/>
-                      </a:pPr>
-                      <a:r>
-                        <a:rPr b="1"/>
-                        <a:t>0.548</a:t>
+                        <a:t>the scan five minutes earlier added, features averaged</a:t>
                       </a:r>
                     </a:p>
                   </a:txBody>
@@ -5643,7 +5495,7 @@
                       </a:pPr>
                       <a:r>
                         <a:rPr/>
-                        <a:t>69 found, 564 false alarms</a:t>
+                        <a:t>does a second scan carry anything the first doesn’t?</a:t>
                       </a:r>
                     </a:p>
                   </a:txBody>
@@ -5655,37 +5507,28 @@
                     <a:bodyPr/>
                     <a:lstStyle/>
                     <a:p>
+                      <a:pPr lvl="0" indent="0" marL="0" algn="ctr">
+                        <a:buNone/>
+                      </a:pPr>
+                      <a:r>
+                        <a:rPr/>
+                        <a:t>3</a:t>
+                      </a:r>
+                    </a:p>
+                  </a:txBody>
+                </a:tc>
+                <a:tc>
+                  <a:txBody>
+                    <a:bodyPr/>
+                    <a:lstStyle/>
+                    <a:p>
                       <a:pPr lvl="0" indent="0" marL="0" algn="l">
                         <a:buNone/>
                       </a:pPr>
                       <a:r>
                         <a:rPr/>
-                        <a:t>current scan, MLP head</a:t>
-                      </a:r>
-                    </a:p>
-                  </a:txBody>
-                </a:tc>
-                <a:tc>
-                  <a:txBody>
-                    <a:bodyPr/>
-                    <a:lstStyle/>
-                    <a:p>
-                      <a:pPr lvl="0" indent="0" marL="0" algn="ctr">
-                        <a:buNone/>
-                      </a:pPr>
-                      <a:r>
-                        <a:rPr/>
-                        <a:t>0.670</a:t>
-                      </a:r>
-                    </a:p>
-                  </a:txBody>
-                </a:tc>
-                <a:tc>
-                  <a:txBody>
-                    <a:bodyPr/>
-                    <a:lstStyle/>
-                    <a:p>
-                      <a:endParaRPr/>
+                        <a:t>frozen CNN, both scans, the authors’ head retrained on +5 / +10 labels</a:t>
+                      </a:r>
                     </a:p>
                   </a:txBody>
                 </a:tc>
@@ -5699,7 +5542,7 @@
                       </a:pPr>
                       <a:r>
                         <a:rPr/>
-                        <a:t>not selected</a:t>
+                        <a:t>can the features be re-aimed at “will it appear”?</a:t>
                       </a:r>
                     </a:p>
                   </a:txBody>
@@ -5711,37 +5554,28 @@
                     <a:bodyPr/>
                     <a:lstStyle/>
                     <a:p>
+                      <a:pPr lvl="0" indent="0" marL="0" algn="ctr">
+                        <a:buNone/>
+                      </a:pPr>
+                      <a:r>
+                        <a:rPr/>
+                        <a:t>4</a:t>
+                      </a:r>
+                    </a:p>
+                  </a:txBody>
+                </a:tc>
+                <a:tc>
+                  <a:txBody>
+                    <a:bodyPr/>
+                    <a:lstStyle/>
+                    <a:p>
                       <a:pPr lvl="0" indent="0" marL="0" algn="l">
                         <a:buNone/>
                       </a:pPr>
                       <a:r>
                         <a:rPr/>
-                        <a:t>warned negatives ×2</a:t>
-                      </a:r>
-                    </a:p>
-                  </a:txBody>
-                </a:tc>
-                <a:tc>
-                  <a:txBody>
-                    <a:bodyPr/>
-                    <a:lstStyle/>
-                    <a:p>
-                      <a:pPr lvl="0" indent="0" marL="0" algn="ctr">
-                        <a:buNone/>
-                      </a:pPr>
-                      <a:r>
-                        <a:rPr/>
-                        <a:t>0.656</a:t>
-                      </a:r>
-                    </a:p>
-                  </a:txBody>
-                </a:tc>
-                <a:tc>
-                  <a:txBody>
-                    <a:bodyPr/>
-                    <a:lstStyle/>
-                    <a:p>
-                      <a:endParaRPr/>
+                        <a:t>the CNN unfrozen</a:t>
+                      </a:r>
                     </a:p>
                   </a:txBody>
                 </a:tc>
@@ -5755,7 +5589,7 @@
                       </a:pPr>
                       <a:r>
                         <a:rPr/>
-                        <a:t>not selected</a:t>
+                        <a:t>does adapting the features buy more?</a:t>
                       </a:r>
                     </a:p>
                   </a:txBody>
@@ -5789,42 +5623,417 @@
       </p:grpSpPr>
       <p:sp>
         <p:nvSpPr>
-          <p:cNvPr id="3" name="Content Placeholder 2"/>
-          <p:cNvSpPr>
-            <a:spLocks noGrp="1"/>
-          </p:cNvSpPr>
+          <p:cNvPr id="2" name="Title 1"/>
+          <p:cNvSpPr>
+            <a:spLocks noGrp="1"/>
+          </p:cNvSpPr>
+          <p:nvPr>
+            <p:ph type="title"/>
+          </p:nvPr>
+        </p:nvSpPr>
+        <p:spPr/>
+        <p:txBody>
+          <a:bodyPr/>
+          <a:lstStyle/>
+          <a:p>
+            <a:pPr lvl="0" indent="0" marL="0">
+              <a:buNone/>
+            </a:pPr>
+            <a:r>
+              <a:rPr/>
+              <a:t>Steps 1 and 2: the detection task</a:t>
+            </a:r>
+          </a:p>
+        </p:txBody>
+      </p:sp>
+      <p:graphicFrame>
+        <p:nvGraphicFramePr>
+          <p:cNvPr id="6" name="Content Placeholder 5"/>
+          <p:cNvGraphicFramePr>
+            <a:graphicFrameLocks noGrp="1"/>
+          </p:cNvGraphicFramePr>
           <p:nvPr>
             <p:ph idx="1"/>
           </p:nvPr>
-        </p:nvSpPr>
-        <p:spPr/>
-        <p:txBody>
-          <a:bodyPr/>
-          <a:lstStyle/>
-          <a:p>
-            <a:pPr lvl="0"/>
-            <a:r>
-              <a:rPr b="1"/>
-              <a:t>Step 1: no.</a:t>
-            </a:r>
-            <a:r>
-              <a:rPr/>
-              <a:t> A new head on frozen features doesn’t beat the detector’s own, and neither head capacity nor reweighting changes that</a:t>
-            </a:r>
-          </a:p>
-          <a:p>
-            <a:pPr lvl="0"/>
-            <a:r>
-              <a:rPr b="1"/>
-              <a:t>Step 2: yes, with a caveat.</a:t>
-            </a:r>
-            <a:r>
-              <a:rPr/>
-              <a:t> The second scan was the only change that moved validation and it carried to test, but false alarms doubled and the paired interval on the gain, [−0.06, +0.16], includes zero</a:t>
-            </a:r>
-          </a:p>
-        </p:txBody>
-      </p:sp>
+        </p:nvGraphicFramePr>
+        <p:xfrm>
+          <a:off x="457200" y="1193800"/>
+          <a:ext cx="8229600" cy="3390900"/>
+        </p:xfrm>
+        <a:graphic>
+          <a:graphicData uri="http://schemas.openxmlformats.org/drawingml/2006/table">
+            <a:tbl>
+              <a:tblPr firstRow="1" bandRow="1">
+                <a:tableStyleId>{5C22544A-7EE6-4342-B048-85BDC9FD1C3A}</a:tableStyleId>
+              </a:tblPr>
+              <a:tblGrid>
+                <a:gridCol w="1765300"/>
+                <a:gridCol w="2349500"/>
+                <a:gridCol w="2349500"/>
+                <a:gridCol w="1765300"/>
+              </a:tblGrid>
+              <a:tr h="0">
+                <a:tc>
+                  <a:txBody>
+                    <a:bodyPr/>
+                    <a:lstStyle/>
+                    <a:p>
+                      <a:pPr lvl="0" indent="0" marL="0" algn="l">
+                        <a:buNone/>
+                      </a:pPr>
+                      <a:r>
+                        <a:rPr/>
+                        <a:t>configuration</a:t>
+                      </a:r>
+                    </a:p>
+                  </a:txBody>
+                  <a:tcPr/>
+                </a:tc>
+                <a:tc>
+                  <a:txBody>
+                    <a:bodyPr/>
+                    <a:lstStyle/>
+                    <a:p>
+                      <a:pPr lvl="0" indent="0" marL="0" algn="ctr">
+                        <a:buNone/>
+                      </a:pPr>
+                      <a:r>
+                        <a:rPr/>
+                        <a:t>validation AP</a:t>
+                      </a:r>
+                    </a:p>
+                  </a:txBody>
+                  <a:tcPr/>
+                </a:tc>
+                <a:tc>
+                  <a:txBody>
+                    <a:bodyPr/>
+                    <a:lstStyle/>
+                    <a:p>
+                      <a:pPr lvl="0" indent="0" marL="0" algn="ctr">
+                        <a:buNone/>
+                      </a:pPr>
+                      <a:r>
+                        <a:rPr/>
+                        <a:t>test AP</a:t>
+                      </a:r>
+                    </a:p>
+                  </a:txBody>
+                  <a:tcPr/>
+                </a:tc>
+                <a:tc>
+                  <a:txBody>
+                    <a:bodyPr/>
+                    <a:lstStyle/>
+                    <a:p>
+                      <a:pPr lvl="0" indent="0" marL="0" algn="l">
+                        <a:buNone/>
+                      </a:pPr>
+                      <a:r>
+                        <a:rPr/>
+                        <a:t>at the locked threshold</a:t>
+                      </a:r>
+                    </a:p>
+                  </a:txBody>
+                  <a:tcPr/>
+                </a:tc>
+              </a:tr>
+              <a:tr h="0">
+                <a:tc>
+                  <a:txBody>
+                    <a:bodyPr/>
+                    <a:lstStyle/>
+                    <a:p>
+                      <a:pPr lvl="0" indent="0" marL="0" algn="l">
+                        <a:buNone/>
+                      </a:pPr>
+                      <a:r>
+                        <a:rPr/>
+                        <a:t>original pretrained CNN</a:t>
+                      </a:r>
+                    </a:p>
+                  </a:txBody>
+                </a:tc>
+                <a:tc>
+                  <a:txBody>
+                    <a:bodyPr/>
+                    <a:lstStyle/>
+                    <a:p>
+                      <a:endParaRPr/>
+                    </a:p>
+                  </a:txBody>
+                </a:tc>
+                <a:tc>
+                  <a:txBody>
+                    <a:bodyPr/>
+                    <a:lstStyle/>
+                    <a:p>
+                      <a:pPr lvl="0" indent="0" marL="0" algn="ctr">
+                        <a:buNone/>
+                      </a:pPr>
+                      <a:r>
+                        <a:rPr/>
+                        <a:t>0.517</a:t>
+                      </a:r>
+                    </a:p>
+                  </a:txBody>
+                </a:tc>
+                <a:tc>
+                  <a:txBody>
+                    <a:bodyPr/>
+                    <a:lstStyle/>
+                    <a:p>
+                      <a:pPr lvl="0" indent="0" marL="0" algn="l">
+                        <a:buNone/>
+                      </a:pPr>
+                      <a:r>
+                        <a:rPr/>
+                        <a:t>68 of 89 found, 276 false alarms</a:t>
+                      </a:r>
+                    </a:p>
+                  </a:txBody>
+                </a:tc>
+              </a:tr>
+              <a:tr h="0">
+                <a:tc>
+                  <a:txBody>
+                    <a:bodyPr/>
+                    <a:lstStyle/>
+                    <a:p>
+                      <a:pPr lvl="0" indent="0" marL="0" algn="l">
+                        <a:buNone/>
+                      </a:pPr>
+                      <a:r>
+                        <a:rPr/>
+                        <a:t>step 1: current scan, linear head</a:t>
+                      </a:r>
+                    </a:p>
+                  </a:txBody>
+                </a:tc>
+                <a:tc>
+                  <a:txBody>
+                    <a:bodyPr/>
+                    <a:lstStyle/>
+                    <a:p>
+                      <a:pPr lvl="0" indent="0" marL="0" algn="ctr">
+                        <a:buNone/>
+                      </a:pPr>
+                      <a:r>
+                        <a:rPr/>
+                        <a:t>0.658</a:t>
+                      </a:r>
+                    </a:p>
+                  </a:txBody>
+                </a:tc>
+                <a:tc>
+                  <a:txBody>
+                    <a:bodyPr/>
+                    <a:lstStyle/>
+                    <a:p>
+                      <a:pPr lvl="0" indent="0" marL="0" algn="ctr">
+                        <a:buNone/>
+                      </a:pPr>
+                      <a:r>
+                        <a:rPr/>
+                        <a:t>0.508</a:t>
+                      </a:r>
+                    </a:p>
+                  </a:txBody>
+                </a:tc>
+                <a:tc>
+                  <a:txBody>
+                    <a:bodyPr/>
+                    <a:lstStyle/>
+                    <a:p>
+                      <a:pPr lvl="0" indent="0" marL="0" algn="l">
+                        <a:buNone/>
+                      </a:pPr>
+                      <a:r>
+                        <a:rPr/>
+                        <a:t>70 found, 571 false alarms</a:t>
+                      </a:r>
+                    </a:p>
+                  </a:txBody>
+                </a:tc>
+              </a:tr>
+              <a:tr h="0">
+                <a:tc>
+                  <a:txBody>
+                    <a:bodyPr/>
+                    <a:lstStyle/>
+                    <a:p>
+                      <a:pPr lvl="0" indent="0" marL="0" algn="l">
+                        <a:buNone/>
+                      </a:pPr>
+                      <a:r>
+                        <a:rPr/>
+                        <a:t>step 2: two-scan mean, linear head</a:t>
+                      </a:r>
+                    </a:p>
+                  </a:txBody>
+                </a:tc>
+                <a:tc>
+                  <a:txBody>
+                    <a:bodyPr/>
+                    <a:lstStyle/>
+                    <a:p>
+                      <a:pPr lvl="0" indent="0" marL="0" algn="ctr">
+                        <a:buNone/>
+                      </a:pPr>
+                      <a:r>
+                        <a:rPr b="1"/>
+                        <a:t>0.675</a:t>
+                      </a:r>
+                    </a:p>
+                  </a:txBody>
+                </a:tc>
+                <a:tc>
+                  <a:txBody>
+                    <a:bodyPr/>
+                    <a:lstStyle/>
+                    <a:p>
+                      <a:pPr lvl="0" indent="0" marL="0" algn="ctr">
+                        <a:buNone/>
+                      </a:pPr>
+                      <a:r>
+                        <a:rPr b="1"/>
+                        <a:t>0.548</a:t>
+                      </a:r>
+                    </a:p>
+                  </a:txBody>
+                </a:tc>
+                <a:tc>
+                  <a:txBody>
+                    <a:bodyPr/>
+                    <a:lstStyle/>
+                    <a:p>
+                      <a:pPr lvl="0" indent="0" marL="0" algn="l">
+                        <a:buNone/>
+                      </a:pPr>
+                      <a:r>
+                        <a:rPr/>
+                        <a:t>69 found, 564 false alarms</a:t>
+                      </a:r>
+                    </a:p>
+                  </a:txBody>
+                </a:tc>
+              </a:tr>
+              <a:tr h="0">
+                <a:tc>
+                  <a:txBody>
+                    <a:bodyPr/>
+                    <a:lstStyle/>
+                    <a:p>
+                      <a:pPr lvl="0" indent="0" marL="0" algn="l">
+                        <a:buNone/>
+                      </a:pPr>
+                      <a:r>
+                        <a:rPr/>
+                        <a:t>current scan, MLP head</a:t>
+                      </a:r>
+                    </a:p>
+                  </a:txBody>
+                </a:tc>
+                <a:tc>
+                  <a:txBody>
+                    <a:bodyPr/>
+                    <a:lstStyle/>
+                    <a:p>
+                      <a:pPr lvl="0" indent="0" marL="0" algn="ctr">
+                        <a:buNone/>
+                      </a:pPr>
+                      <a:r>
+                        <a:rPr/>
+                        <a:t>0.670</a:t>
+                      </a:r>
+                    </a:p>
+                  </a:txBody>
+                </a:tc>
+                <a:tc>
+                  <a:txBody>
+                    <a:bodyPr/>
+                    <a:lstStyle/>
+                    <a:p>
+                      <a:endParaRPr/>
+                    </a:p>
+                  </a:txBody>
+                </a:tc>
+                <a:tc>
+                  <a:txBody>
+                    <a:bodyPr/>
+                    <a:lstStyle/>
+                    <a:p>
+                      <a:pPr lvl="0" indent="0" marL="0" algn="l">
+                        <a:buNone/>
+                      </a:pPr>
+                      <a:r>
+                        <a:rPr/>
+                        <a:t>not selected</a:t>
+                      </a:r>
+                    </a:p>
+                  </a:txBody>
+                </a:tc>
+              </a:tr>
+              <a:tr h="0">
+                <a:tc>
+                  <a:txBody>
+                    <a:bodyPr/>
+                    <a:lstStyle/>
+                    <a:p>
+                      <a:pPr lvl="0" indent="0" marL="0" algn="l">
+                        <a:buNone/>
+                      </a:pPr>
+                      <a:r>
+                        <a:rPr/>
+                        <a:t>warned negatives ×2</a:t>
+                      </a:r>
+                    </a:p>
+                  </a:txBody>
+                </a:tc>
+                <a:tc>
+                  <a:txBody>
+                    <a:bodyPr/>
+                    <a:lstStyle/>
+                    <a:p>
+                      <a:pPr lvl="0" indent="0" marL="0" algn="ctr">
+                        <a:buNone/>
+                      </a:pPr>
+                      <a:r>
+                        <a:rPr/>
+                        <a:t>0.656</a:t>
+                      </a:r>
+                    </a:p>
+                  </a:txBody>
+                </a:tc>
+                <a:tc>
+                  <a:txBody>
+                    <a:bodyPr/>
+                    <a:lstStyle/>
+                    <a:p>
+                      <a:endParaRPr/>
+                    </a:p>
+                  </a:txBody>
+                </a:tc>
+                <a:tc>
+                  <a:txBody>
+                    <a:bodyPr/>
+                    <a:lstStyle/>
+                    <a:p>
+                      <a:pPr lvl="0" indent="0" marL="0" algn="l">
+                        <a:buNone/>
+                      </a:pPr>
+                      <a:r>
+                        <a:rPr/>
+                        <a:t>not selected</a:t>
+                      </a:r>
+                    </a:p>
+                  </a:txBody>
+                </a:tc>
+              </a:tr>
+            </a:tbl>
+          </a:graphicData>
+        </a:graphic>
+      </p:graphicFrame>
     </p:spTree>
   </p:cSld>
 </p:sld>

</xml_diff>

<commit_message>
Slides: fit the step 1-2 reading
</commit_message>
<xml_diff>
--- a/slides.pptx
+++ b/slides.pptx
@@ -3286,7 +3286,7 @@
             </a:r>
             <a:r>
               <a:rPr/>
-              <a:t> The second scan was the only change that moved validation, and it carried to test</a:t>
+              <a:t> The second scan was the only change that moved validation and it carried to test, so it carries signal the first scan doesn’t</a:t>
             </a:r>
           </a:p>
           <a:p>
@@ -3294,13 +3294,6 @@
             <a:r>
               <a:rPr/>
               <a:t>But false alarms doubled at the same recall, and the paired interval on the gain, [−0.06, +0.16], includes zero</a:t>
-            </a:r>
-          </a:p>
-          <a:p>
-            <a:pPr lvl="0"/>
-            <a:r>
-              <a:rPr/>
-              <a:t>What it establishes: the second scan carries signal the first doesn’t</a:t>
             </a:r>
           </a:p>
         </p:txBody>

</xml_diff>

<commit_message>
Slides: shorter step 1-2 reading
</commit_message>
<xml_diff>
--- a/slides.pptx
+++ b/slides.pptx
@@ -3268,14 +3268,14 @@
             </a:r>
             <a:r>
               <a:rPr/>
-              <a:t> A new head on the frozen features doesn’t beat the detector’s own, and neither more head capacity nor reweighting the hard negatives changes that</a:t>
+              <a:t> A new head on the frozen features doesn’t beat the detector’s own, and neither head capacity nor reweighting changes that</a:t>
             </a:r>
           </a:p>
           <a:p>
             <a:pPr lvl="0"/>
             <a:r>
               <a:rPr/>
-              <a:t>The detector’s readout of its features is about as good as those features get: anything more needs new information, not a better readout</a:t>
+              <a:t>Its readout is about as good as its features get: more needs new information, not a better readout</a:t>
             </a:r>
           </a:p>
           <a:p>
@@ -3286,7 +3286,7 @@
             </a:r>
             <a:r>
               <a:rPr/>
-              <a:t> The second scan was the only change that moved validation and it carried to test, so it carries signal the first scan doesn’t</a:t>
+              <a:t> Only the second scan moved validation, and it carried to test: it carries signal the first scan doesn’t</a:t>
             </a:r>
           </a:p>
           <a:p>

</xml_diff>

<commit_message>
Exports: proportional table columns, full-width figures outside PDF, Word cell alignment fix
</commit_message>
<xml_diff>
--- a/slides.pptx
+++ b/slides.pptx
@@ -3443,9 +3443,9 @@
                 <a:tableStyleId>{5C22544A-7EE6-4342-B048-85BDC9FD1C3A}</a:tableStyleId>
               </a:tblPr>
               <a:tblGrid>
-                <a:gridCol w="2247900"/>
-                <a:gridCol w="2997200"/>
-                <a:gridCol w="2997200"/>
+                <a:gridCol w="4292600"/>
+                <a:gridCol w="1968500"/>
+                <a:gridCol w="1968500"/>
               </a:tblGrid>
               <a:tr h="0">
                 <a:tc>
@@ -3794,10 +3794,10 @@
                 <a:tableStyleId>{5C22544A-7EE6-4342-B048-85BDC9FD1C3A}</a:tableStyleId>
               </a:tblPr>
               <a:tblGrid>
-                <a:gridCol w="1295400"/>
+                <a:gridCol w="1854200"/>
+                <a:gridCol w="1460500"/>
                 <a:gridCol w="1727200"/>
-                <a:gridCol w="1727200"/>
-                <a:gridCol w="1727200"/>
+                <a:gridCol w="1460500"/>
                 <a:gridCol w="1727200"/>
               </a:tblGrid>
               <a:tr h="0">
@@ -5299,9 +5299,9 @@
                 <a:tableStyleId>{5C22544A-7EE6-4342-B048-85BDC9FD1C3A}</a:tableStyleId>
               </a:tblPr>
               <a:tblGrid>
-                <a:gridCol w="3289300"/>
-                <a:gridCol w="2463800"/>
-                <a:gridCol w="2463800"/>
+                <a:gridCol w="812800"/>
+                <a:gridCol w="3708400"/>
+                <a:gridCol w="3708400"/>
               </a:tblGrid>
               <a:tr h="0">
                 <a:tc>
@@ -5660,10 +5660,10 @@
                 <a:tableStyleId>{5C22544A-7EE6-4342-B048-85BDC9FD1C3A}</a:tableStyleId>
               </a:tblPr>
               <a:tblGrid>
-                <a:gridCol w="1765300"/>
-                <a:gridCol w="2349500"/>
-                <a:gridCol w="2349500"/>
-                <a:gridCol w="1765300"/>
+                <a:gridCol w="2743200"/>
+                <a:gridCol w="1524000"/>
+                <a:gridCol w="1219200"/>
+                <a:gridCol w="2743200"/>
               </a:tblGrid>
               <a:tr h="0">
                 <a:tc>

</xml_diff>